<commit_message>
2.0.5 - rewrite the original 23 presentation slides to the refreshed project
</commit_message>
<xml_diff>
--- a/docs/House Price.pptx
+++ b/docs/House Price.pptx
@@ -6455,121 +6455,15 @@
               </a:lnSpc>
             </a:pPr>
             <a:r>
-              <a:rPr lang="en-IN" sz="2000" dirty="0" smtClean="0">
-                <a:latin typeface="Times New Roman" panose="02020603050405020304" pitchFamily="18" charset="0"/>
-                <a:cs typeface="Times New Roman" panose="02020603050405020304" pitchFamily="18" charset="0"/>
+              <a:rPr sz="2000">
+                <a:latin typeface="Times New Roman"/>
               </a:rPr>
-              <a:t>The </a:t>
-            </a:r>
-            <a:r>
-              <a:rPr lang="en-IN" sz="2000" dirty="0">
-                <a:latin typeface="Times New Roman" panose="02020603050405020304" pitchFamily="18" charset="0"/>
-                <a:cs typeface="Times New Roman" panose="02020603050405020304" pitchFamily="18" charset="0"/>
-              </a:rPr>
-              <a:t>input data was collected from dataset repository like UCI </a:t>
-            </a:r>
-            <a:r>
-              <a:rPr lang="en-IN" sz="2000" dirty="0" smtClean="0">
-                <a:latin typeface="Times New Roman" panose="02020603050405020304" pitchFamily="18" charset="0"/>
-                <a:cs typeface="Times New Roman" panose="02020603050405020304" pitchFamily="18" charset="0"/>
-              </a:rPr>
-              <a:t>repository. In here, I used Kaggle. </a:t>
+              <a:t>The input data is collected from Kaggle - the 'Bengaluru House price data' set (CC0 license), a historical snapshot of listings from roughly 2017-2020. The dataset contains 13,320 listings with 9 columns: area type, availability, location, size, society, total area, bathrooms, balconies and price (Lakh INR).</a:t>
             </a:r>
             <a:endParaRPr lang="en-IN" sz="2000" dirty="0">
               <a:latin typeface="Times New Roman" panose="02020603050405020304" pitchFamily="18" charset="0"/>
               <a:cs typeface="Times New Roman" panose="02020603050405020304" pitchFamily="18" charset="0"/>
             </a:endParaRPr>
-          </a:p>
-          <a:p>
-            <a:pPr lvl="0" algn="just">
-              <a:lnSpc>
-                <a:spcPct val="150000"/>
-              </a:lnSpc>
-            </a:pPr>
-            <a:r>
-              <a:rPr lang="en-IN" sz="2000" dirty="0" smtClean="0">
-                <a:latin typeface="Times New Roman" panose="02020603050405020304" pitchFamily="18" charset="0"/>
-                <a:cs typeface="Times New Roman" panose="02020603050405020304" pitchFamily="18" charset="0"/>
-              </a:rPr>
-              <a:t>In </a:t>
-            </a:r>
-            <a:r>
-              <a:rPr lang="en-IN" sz="2000" dirty="0">
-                <a:latin typeface="Times New Roman" panose="02020603050405020304" pitchFamily="18" charset="0"/>
-                <a:cs typeface="Times New Roman" panose="02020603050405020304" pitchFamily="18" charset="0"/>
-              </a:rPr>
-              <a:t>our process, house dataset is used.</a:t>
-            </a:r>
-          </a:p>
-          <a:p>
-            <a:pPr lvl="0" algn="just">
-              <a:lnSpc>
-                <a:spcPct val="150000"/>
-              </a:lnSpc>
-            </a:pPr>
-            <a:r>
-              <a:rPr lang="en-IN" sz="2000" dirty="0" smtClean="0">
-                <a:latin typeface="Times New Roman" panose="02020603050405020304" pitchFamily="18" charset="0"/>
-                <a:cs typeface="Times New Roman" panose="02020603050405020304" pitchFamily="18" charset="0"/>
-              </a:rPr>
-              <a:t>The </a:t>
-            </a:r>
-            <a:r>
-              <a:rPr lang="en-IN" sz="2000" dirty="0">
-                <a:latin typeface="Times New Roman" panose="02020603050405020304" pitchFamily="18" charset="0"/>
-                <a:cs typeface="Times New Roman" panose="02020603050405020304" pitchFamily="18" charset="0"/>
-              </a:rPr>
-              <a:t>data selection is the process of predicting the house price.</a:t>
-            </a:r>
-          </a:p>
-          <a:p>
-            <a:pPr lvl="0" algn="just">
-              <a:lnSpc>
-                <a:spcPct val="150000"/>
-              </a:lnSpc>
-            </a:pPr>
-            <a:r>
-              <a:rPr lang="en-IN" sz="2000" dirty="0" smtClean="0">
-                <a:latin typeface="Times New Roman" panose="02020603050405020304" pitchFamily="18" charset="0"/>
-                <a:cs typeface="Times New Roman" panose="02020603050405020304" pitchFamily="18" charset="0"/>
-              </a:rPr>
-              <a:t>The </a:t>
-            </a:r>
-            <a:r>
-              <a:rPr lang="en-IN" sz="2000" dirty="0">
-                <a:latin typeface="Times New Roman" panose="02020603050405020304" pitchFamily="18" charset="0"/>
-                <a:cs typeface="Times New Roman" panose="02020603050405020304" pitchFamily="18" charset="0"/>
-              </a:rPr>
-              <a:t>dataset contains the information about the house like </a:t>
-            </a:r>
-            <a:r>
-              <a:rPr lang="en-IN" sz="2000" dirty="0" smtClean="0">
-                <a:latin typeface="Times New Roman" panose="02020603050405020304" pitchFamily="18" charset="0"/>
-                <a:cs typeface="Times New Roman" panose="02020603050405020304" pitchFamily="18" charset="0"/>
-              </a:rPr>
-              <a:t>location, area, square </a:t>
-            </a:r>
-            <a:r>
-              <a:rPr lang="en-IN" sz="2000" dirty="0">
-                <a:latin typeface="Times New Roman" panose="02020603050405020304" pitchFamily="18" charset="0"/>
-                <a:cs typeface="Times New Roman" panose="02020603050405020304" pitchFamily="18" charset="0"/>
-              </a:rPr>
-              <a:t>root, bed </a:t>
-            </a:r>
-            <a:r>
-              <a:rPr lang="en-IN" sz="2000" dirty="0" smtClean="0">
-                <a:latin typeface="Times New Roman" panose="02020603050405020304" pitchFamily="18" charset="0"/>
-                <a:cs typeface="Times New Roman" panose="02020603050405020304" pitchFamily="18" charset="0"/>
-              </a:rPr>
-              <a:t>room, area type, availability, </a:t>
-            </a:r>
-            <a:r>
-              <a:rPr lang="en-IN" sz="2000" dirty="0">
-                <a:latin typeface="Times New Roman" panose="02020603050405020304" pitchFamily="18" charset="0"/>
-                <a:cs typeface="Times New Roman" panose="02020603050405020304" pitchFamily="18" charset="0"/>
-              </a:rPr>
-              <a:t>bath square feet and so on.,</a:t>
-            </a:r>
           </a:p>
         </p:txBody>
       </p:sp>
@@ -6760,6 +6654,35 @@
           </a:p>
         </p:txBody>
       </p:sp>
+      <p:sp>
+        <p:nvSpPr>
+          <p:cNvPr id="7" name="TextBox 6"/>
+          <p:cNvSpPr txBox="1"/>
+          <p:nvPr/>
+        </p:nvSpPr>
+        <p:spPr>
+          <a:xfrm>
+            <a:off x="3425311" y="2063077"/>
+            <a:ext cx="4457700" cy="2400300"/>
+          </a:xfrm>
+          <a:prstGeom prst="rect">
+            <a:avLst/>
+          </a:prstGeom>
+          <a:noFill/>
+        </p:spPr>
+        <p:txBody>
+          <a:bodyPr wrap="square">
+            <a:spAutoFit/>
+          </a:bodyPr>
+          <a:lstStyle/>
+          <a:p>
+            <a:r>
+              <a:rPr sz="1600"/>
+              <a:t>13,320 rows x 9 columns   -   ~1,100 locations   -   ~2,700 societies   -   price in Lakh INR   -   41% of listings have no society name</a:t>
+            </a:r>
+          </a:p>
+        </p:txBody>
+      </p:sp>
     </p:spTree>
     <p:extLst>
       <p:ext uri="{BB962C8B-B14F-4D97-AF65-F5344CB8AC3E}">
@@ -6871,76 +6794,11 @@
               </a:lnSpc>
             </a:pPr>
             <a:r>
-              <a:rPr lang="en-IN" sz="2000" dirty="0">
-                <a:latin typeface="Times New Roman" panose="02020603050405020304" pitchFamily="18" charset="0"/>
-                <a:cs typeface="Times New Roman" panose="02020603050405020304" pitchFamily="18" charset="0"/>
+              <a:rPr sz="2000">
+                <a:latin typeface="Times New Roman"/>
               </a:rPr>
-              <a:t>Data pre-processing is the process of removing the unwanted data from the dataset. </a:t>
-            </a:r>
-          </a:p>
-          <a:p>
-            <a:pPr lvl="0" algn="just">
-              <a:lnSpc>
-                <a:spcPct val="150000"/>
-              </a:lnSpc>
-            </a:pPr>
-            <a:r>
-              <a:rPr lang="en-IN" sz="2000" dirty="0">
-                <a:latin typeface="Times New Roman" panose="02020603050405020304" pitchFamily="18" charset="0"/>
-                <a:cs typeface="Times New Roman" panose="02020603050405020304" pitchFamily="18" charset="0"/>
-              </a:rPr>
-              <a:t>Pre-processing data transformation operations are used to transform the dataset into a structure suitable for machine learning. </a:t>
-            </a:r>
-          </a:p>
-          <a:p>
-            <a:pPr lvl="0" algn="just">
-              <a:lnSpc>
-                <a:spcPct val="150000"/>
-              </a:lnSpc>
-            </a:pPr>
-            <a:r>
-              <a:rPr lang="en-IN" sz="2000" dirty="0">
-                <a:latin typeface="Times New Roman" panose="02020603050405020304" pitchFamily="18" charset="0"/>
-                <a:cs typeface="Times New Roman" panose="02020603050405020304" pitchFamily="18" charset="0"/>
-              </a:rPr>
-              <a:t> Missing data removal: In this process, the null values such as missing values and Nan values are replaced by 0.</a:t>
-            </a:r>
-          </a:p>
-          <a:p>
-            <a:pPr lvl="0" algn="just">
-              <a:lnSpc>
-                <a:spcPct val="150000"/>
-              </a:lnSpc>
-            </a:pPr>
-            <a:r>
-              <a:rPr lang="en-IN" sz="2000" dirty="0">
-                <a:latin typeface="Times New Roman" panose="02020603050405020304" pitchFamily="18" charset="0"/>
-                <a:cs typeface="Times New Roman" panose="02020603050405020304" pitchFamily="18" charset="0"/>
-              </a:rPr>
-              <a:t> Encoding Categorical data: That categorical data is defined as variables with a finite set of label </a:t>
-            </a:r>
-            <a:r>
-              <a:rPr lang="en-IN" sz="2000" dirty="0" smtClean="0">
-                <a:latin typeface="Times New Roman" panose="02020603050405020304" pitchFamily="18" charset="0"/>
-                <a:cs typeface="Times New Roman" panose="02020603050405020304" pitchFamily="18" charset="0"/>
-              </a:rPr>
-              <a:t>values like 0,1,2,3...etc.,</a:t>
-            </a:r>
-            <a:endParaRPr lang="en-IN" sz="2000" dirty="0">
-              <a:latin typeface="Times New Roman" panose="02020603050405020304" pitchFamily="18" charset="0"/>
-              <a:cs typeface="Times New Roman" panose="02020603050405020304" pitchFamily="18" charset="0"/>
-            </a:endParaRPr>
-          </a:p>
-          <a:p>
-            <a:pPr algn="just">
-              <a:lnSpc>
-                <a:spcPct val="150000"/>
-              </a:lnSpc>
-            </a:pPr>
-            <a:endParaRPr lang="en-IN" sz="2000" dirty="0">
-              <a:latin typeface="Times New Roman" panose="02020603050405020304" pitchFamily="18" charset="0"/>
-              <a:cs typeface="Times New Roman" panose="02020603050405020304" pitchFamily="18" charset="0"/>
-            </a:endParaRPr>
+              <a:t>Pre-processing is the process of removing and correcting unreliable data. Area values in other units (sq.meter, sq.yards, acre, perch) are converted to sqft and ranges are replaced by their midpoint. 59 rows (0.4%) with physically impossible measurements - e.g. an 11 sqft 3-bedroom flat or a 52,272 sqft house - are dropped. Missing baths/balconies are set to 0 and missing location/society are given a dedicated 'not available' category.</a:t>
+            </a:r>
           </a:p>
         </p:txBody>
       </p:sp>
@@ -7131,22 +6989,53 @@
           </a:p>
         </p:txBody>
       </p:sp>
+      <p:sp>
+        <p:nvSpPr>
+          <p:cNvPr id="8" name="TextBox 7"/>
+          <p:cNvSpPr txBox="1"/>
+          <p:nvPr/>
+        </p:nvSpPr>
+        <p:spPr>
+          <a:xfrm>
+            <a:off x="1225312" y="2407444"/>
+            <a:ext cx="4286845" cy="2460770"/>
+          </a:xfrm>
+          <a:prstGeom prst="rect">
+            <a:avLst/>
+          </a:prstGeom>
+          <a:noFill/>
+        </p:spPr>
+        <p:txBody>
+          <a:bodyPr wrap="square">
+            <a:spAutoFit/>
+          </a:bodyPr>
+          <a:lstStyle/>
+          <a:p>
+            <a:r>
+              <a:rPr sz="1600"/>
+              <a:t>Feature engineering converts raw labels into model features: size -&gt; BHK count (Studio/RK -&gt; 0/1), availability -&gt; completion year (0 = ready to move), area type -&gt; label encoding, and location &amp; society -&gt; frequency encoding (how often the value appears in the training split - no fake ordering, no thousands of sparse columns).</a:t>
+            </a:r>
+          </a:p>
+        </p:txBody>
+      </p:sp>
       <p:pic>
         <p:nvPicPr>
-          <p:cNvPr id="7" name="Picture 6"/>
-          <p:cNvPicPr/>
+          <p:cNvPr id="9" name="Picture 8" descr="missing_values.png"/>
+          <p:cNvPicPr>
+            <a:picLocks noChangeAspect="1"/>
+          </p:cNvPicPr>
           <p:nvPr/>
         </p:nvPicPr>
         <p:blipFill>
-          <a:blip r:embed="rId3"/>
+          <a:blip r:embed="rId4"/>
           <a:stretch>
             <a:fillRect/>
           </a:stretch>
         </p:blipFill>
         <p:spPr>
           <a:xfrm>
-            <a:off x="6711642" y="2407444"/>
-            <a:ext cx="4441462" cy="2460770"/>
+            <a:off x="6675120" y="2405575"/>
+            <a:ext cx="4480560" cy="2412609"/>
           </a:xfrm>
           <a:prstGeom prst="rect">
             <a:avLst/>
@@ -7277,20 +7166,22 @@
       </p:sp>
       <p:pic>
         <p:nvPicPr>
-          <p:cNvPr id="8" name="Picture 7"/>
-          <p:cNvPicPr/>
+          <p:cNvPr id="10" name="Picture 9" descr="price_vs_sqft.png"/>
+          <p:cNvPicPr>
+            <a:picLocks noChangeAspect="1"/>
+          </p:cNvPicPr>
           <p:nvPr/>
         </p:nvPicPr>
         <p:blipFill>
-          <a:blip r:embed="rId2"/>
+          <a:blip r:embed="rId4"/>
           <a:stretch>
             <a:fillRect/>
           </a:stretch>
         </p:blipFill>
         <p:spPr>
           <a:xfrm>
-            <a:off x="838200" y="1812925"/>
-            <a:ext cx="4619625" cy="3648075"/>
+            <a:off x="822960" y="2258568"/>
+            <a:ext cx="4663440" cy="2798064"/>
           </a:xfrm>
           <a:prstGeom prst="rect">
             <a:avLst/>
@@ -7299,20 +7190,22 @@
       </p:pic>
       <p:pic>
         <p:nvPicPr>
-          <p:cNvPr id="9" name="Picture 8"/>
-          <p:cNvPicPr/>
+          <p:cNvPr id="11" name="Picture 10" descr="price_by_bhk.png"/>
+          <p:cNvPicPr>
+            <a:picLocks noChangeAspect="1"/>
+          </p:cNvPicPr>
           <p:nvPr/>
         </p:nvPicPr>
         <p:blipFill>
-          <a:blip r:embed="rId3"/>
+          <a:blip r:embed="rId5"/>
           <a:stretch>
             <a:fillRect/>
           </a:stretch>
         </p:blipFill>
         <p:spPr>
           <a:xfrm>
-            <a:off x="7019925" y="1812924"/>
-            <a:ext cx="4333875" cy="3648075"/>
+            <a:off x="7040880" y="2368296"/>
+            <a:ext cx="4297680" cy="2578608"/>
           </a:xfrm>
           <a:prstGeom prst="rect">
             <a:avLst/>
@@ -7430,114 +7323,11 @@
               </a:lnSpc>
             </a:pPr>
             <a:r>
-              <a:rPr lang="en-IN" sz="2000" dirty="0">
-                <a:latin typeface="Times New Roman" panose="02020603050405020304" pitchFamily="18" charset="0"/>
-                <a:cs typeface="Times New Roman" panose="02020603050405020304" pitchFamily="18" charset="0"/>
+              <a:rPr sz="2000">
+                <a:latin typeface="Times New Roman"/>
               </a:rPr>
-              <a:t>During the machine learning process, data are needed so that learning can take place. </a:t>
-            </a:r>
-          </a:p>
-          <a:p>
-            <a:pPr lvl="0" algn="just">
-              <a:lnSpc>
-                <a:spcPct val="150000"/>
-              </a:lnSpc>
-            </a:pPr>
-            <a:r>
-              <a:rPr lang="en-IN" sz="2000" dirty="0">
-                <a:latin typeface="Times New Roman" panose="02020603050405020304" pitchFamily="18" charset="0"/>
-                <a:cs typeface="Times New Roman" panose="02020603050405020304" pitchFamily="18" charset="0"/>
-              </a:rPr>
-              <a:t>In addition to the data required for training, test data are needed to evaluate the performance of the algorithm in order to see how well it works. </a:t>
-            </a:r>
-          </a:p>
-          <a:p>
-            <a:pPr lvl="0" algn="just">
-              <a:lnSpc>
-                <a:spcPct val="150000"/>
-              </a:lnSpc>
-            </a:pPr>
-            <a:r>
-              <a:rPr lang="en-IN" sz="2000" dirty="0">
-                <a:latin typeface="Times New Roman" panose="02020603050405020304" pitchFamily="18" charset="0"/>
-                <a:cs typeface="Times New Roman" panose="02020603050405020304" pitchFamily="18" charset="0"/>
-              </a:rPr>
-              <a:t>In our process, we considered 70</a:t>
-            </a:r>
-            <a:r>
-              <a:rPr lang="en-IN" sz="2000" dirty="0" smtClean="0">
-                <a:latin typeface="Times New Roman" panose="02020603050405020304" pitchFamily="18" charset="0"/>
-                <a:cs typeface="Times New Roman" panose="02020603050405020304" pitchFamily="18" charset="0"/>
-              </a:rPr>
-              <a:t>%(9100+) </a:t>
-            </a:r>
-            <a:r>
-              <a:rPr lang="en-IN" sz="2000" dirty="0">
-                <a:latin typeface="Times New Roman" panose="02020603050405020304" pitchFamily="18" charset="0"/>
-                <a:cs typeface="Times New Roman" panose="02020603050405020304" pitchFamily="18" charset="0"/>
-              </a:rPr>
-              <a:t>of the our dataset to be the training data and the remaining 30</a:t>
-            </a:r>
-            <a:r>
-              <a:rPr lang="en-IN" sz="2000" dirty="0" smtClean="0">
-                <a:latin typeface="Times New Roman" panose="02020603050405020304" pitchFamily="18" charset="0"/>
-                <a:cs typeface="Times New Roman" panose="02020603050405020304" pitchFamily="18" charset="0"/>
-              </a:rPr>
-              <a:t>%(3900+) </a:t>
-            </a:r>
-            <a:r>
-              <a:rPr lang="en-IN" sz="2000" dirty="0">
-                <a:latin typeface="Times New Roman" panose="02020603050405020304" pitchFamily="18" charset="0"/>
-                <a:cs typeface="Times New Roman" panose="02020603050405020304" pitchFamily="18" charset="0"/>
-              </a:rPr>
-              <a:t>to be the testing </a:t>
-            </a:r>
-            <a:r>
-              <a:rPr lang="en-IN" sz="2000" dirty="0" smtClean="0">
-                <a:latin typeface="Times New Roman" panose="02020603050405020304" pitchFamily="18" charset="0"/>
-                <a:cs typeface="Times New Roman" panose="02020603050405020304" pitchFamily="18" charset="0"/>
-              </a:rPr>
-              <a:t>data of  Total(13300+).</a:t>
-            </a:r>
-            <a:endParaRPr lang="en-IN" sz="2000" dirty="0">
-              <a:latin typeface="Times New Roman" panose="02020603050405020304" pitchFamily="18" charset="0"/>
-              <a:cs typeface="Times New Roman" panose="02020603050405020304" pitchFamily="18" charset="0"/>
-            </a:endParaRPr>
-          </a:p>
-          <a:p>
-            <a:pPr lvl="0" algn="just">
-              <a:lnSpc>
-                <a:spcPct val="150000"/>
-              </a:lnSpc>
-            </a:pPr>
-            <a:r>
-              <a:rPr lang="en-US" sz="2000" dirty="0">
-                <a:latin typeface="Times New Roman" panose="02020603050405020304" pitchFamily="18" charset="0"/>
-                <a:cs typeface="Times New Roman" panose="02020603050405020304" pitchFamily="18" charset="0"/>
-              </a:rPr>
-              <a:t>Data splitting is the act of partitioning available data into two portions, usually for cross-validator purposes.  </a:t>
-            </a:r>
-            <a:endParaRPr lang="en-IN" sz="2000" dirty="0">
-              <a:latin typeface="Times New Roman" panose="02020603050405020304" pitchFamily="18" charset="0"/>
-              <a:cs typeface="Times New Roman" panose="02020603050405020304" pitchFamily="18" charset="0"/>
-            </a:endParaRPr>
-          </a:p>
-          <a:p>
-            <a:pPr lvl="0" algn="just">
-              <a:lnSpc>
-                <a:spcPct val="150000"/>
-              </a:lnSpc>
-            </a:pPr>
-            <a:r>
-              <a:rPr lang="en-IN" sz="2000" dirty="0">
-                <a:latin typeface="Times New Roman" panose="02020603050405020304" pitchFamily="18" charset="0"/>
-                <a:cs typeface="Times New Roman" panose="02020603050405020304" pitchFamily="18" charset="0"/>
-              </a:rPr>
-              <a:t>One Portion of the data is used to develop a predictive model and the other to evaluate the model's performance.</a:t>
-            </a:r>
-          </a:p>
-          <a:p>
-            <a:endParaRPr lang="en-IN" sz="2000" dirty="0"/>
+              <a:t>During the machine learning process, data is needed for both training and evaluation. The prepared data is split 70/30 - 9,282 training rows and 3,979 test rows (random state 2). Because prices are strongly right-skewed by a handful of thousand-Lakh listings, the target is log(1 + price). The linear models are fitted on standardized features while the Random Forest uses the raw encoded features, and the frequency maps are built only from the training split so that no test information leaks in.</a:t>
+            </a:r>
           </a:p>
         </p:txBody>
       </p:sp>
@@ -7733,6 +7523,35 @@
           </a:p>
         </p:txBody>
       </p:sp>
+      <p:sp>
+        <p:nvSpPr>
+          <p:cNvPr id="7" name="TextBox 6"/>
+          <p:cNvSpPr txBox="1"/>
+          <p:nvPr/>
+        </p:nvSpPr>
+        <p:spPr>
+          <a:xfrm>
+            <a:off x="2871989" y="2457148"/>
+            <a:ext cx="5937160" cy="2578492"/>
+          </a:xfrm>
+          <a:prstGeom prst="rect">
+            <a:avLst/>
+          </a:prstGeom>
+          <a:noFill/>
+        </p:spPr>
+        <p:txBody>
+          <a:bodyPr wrap="square">
+            <a:spAutoFit/>
+          </a:bodyPr>
+          <a:lstStyle/>
+          <a:p>
+            <a:r>
+              <a:rPr sz="1600"/>
+              <a:t>Train: 9,282 rows   -   Test: 3,979 rows   -   random state 2   -   target: log(1 + price)   -   frequency maps built from the training split only</a:t>
+            </a:r>
+          </a:p>
+        </p:txBody>
+      </p:sp>
     </p:spTree>
     <p:extLst>
       <p:ext uri="{BB962C8B-B14F-4D97-AF65-F5344CB8AC3E}">
@@ -7794,18 +7613,10 @@
           <a:p>
             <a:pPr algn="ctr"/>
             <a:r>
-              <a:rPr lang="en-US" b="1" dirty="0" smtClean="0">
-                <a:effectLst>
-                  <a:outerShdw blurRad="38100" dist="38100" dir="2700000" algn="tl">
-                    <a:srgbClr val="000000">
-                      <a:alpha val="43137"/>
-                    </a:srgbClr>
-                  </a:outerShdw>
-                </a:effectLst>
-                <a:latin typeface="Times New Roman" panose="02020603050405020304" pitchFamily="18" charset="0"/>
-                <a:cs typeface="Times New Roman" panose="02020603050405020304" pitchFamily="18" charset="0"/>
+              <a:rPr b="1">
+                <a:latin typeface="Times New Roman"/>
               </a:rPr>
-              <a:t>CLASSIFICATION</a:t>
+              <a:t>MODEL TRAINING</a:t>
             </a:r>
             <a:endParaRPr lang="en-IN" b="1" dirty="0">
               <a:effectLst>
@@ -7849,74 +7660,10 @@
               </a:lnSpc>
             </a:pPr>
             <a:r>
-              <a:rPr lang="en-IN" sz="2000" dirty="0" smtClean="0">
-                <a:latin typeface="Times New Roman" panose="02020603050405020304" pitchFamily="18" charset="0"/>
-                <a:cs typeface="Times New Roman" panose="02020603050405020304" pitchFamily="18" charset="0"/>
+              <a:rPr sz="2000">
+                <a:latin typeface="Times New Roman"/>
               </a:rPr>
-              <a:t>In </a:t>
-            </a:r>
-            <a:r>
-              <a:rPr lang="en-IN" sz="2000" dirty="0">
-                <a:latin typeface="Times New Roman" panose="02020603050405020304" pitchFamily="18" charset="0"/>
-                <a:cs typeface="Times New Roman" panose="02020603050405020304" pitchFamily="18" charset="0"/>
-              </a:rPr>
-              <a:t>our process, we have to implement the machine learning algorithms such as random forest regression and ridge regression.</a:t>
-            </a:r>
-          </a:p>
-          <a:p>
-            <a:pPr lvl="0" algn="just">
-              <a:lnSpc>
-                <a:spcPct val="150000"/>
-              </a:lnSpc>
-            </a:pPr>
-            <a:r>
-              <a:rPr lang="en-IN" sz="2000" b="1" dirty="0" smtClean="0">
-                <a:latin typeface="Times New Roman" panose="02020603050405020304" pitchFamily="18" charset="0"/>
-                <a:cs typeface="Times New Roman" panose="02020603050405020304" pitchFamily="18" charset="0"/>
-              </a:rPr>
-              <a:t>Ridge </a:t>
-            </a:r>
-            <a:r>
-              <a:rPr lang="en-IN" sz="2000" b="1" dirty="0">
-                <a:latin typeface="Times New Roman" panose="02020603050405020304" pitchFamily="18" charset="0"/>
-                <a:cs typeface="Times New Roman" panose="02020603050405020304" pitchFamily="18" charset="0"/>
-              </a:rPr>
-              <a:t>regression </a:t>
-            </a:r>
-            <a:r>
-              <a:rPr lang="en-IN" sz="2000" dirty="0">
-                <a:latin typeface="Times New Roman" panose="02020603050405020304" pitchFamily="18" charset="0"/>
-                <a:cs typeface="Times New Roman" panose="02020603050405020304" pitchFamily="18" charset="0"/>
-              </a:rPr>
-              <a:t>is a model tuning method that is used to analyse any data that suffers from multicollinearity. This method performs L2 regularization. When the issue of multicollinearity occurs, least-squares are unbiased, and variances are large, this results in predicted values being far away from the actual values.</a:t>
-            </a:r>
-          </a:p>
-          <a:p>
-            <a:pPr lvl="0" algn="just">
-              <a:lnSpc>
-                <a:spcPct val="150000"/>
-              </a:lnSpc>
-            </a:pPr>
-            <a:r>
-              <a:rPr lang="en-IN" sz="2000" b="1" dirty="0" smtClean="0">
-                <a:latin typeface="Times New Roman" panose="02020603050405020304" pitchFamily="18" charset="0"/>
-                <a:cs typeface="Times New Roman" panose="02020603050405020304" pitchFamily="18" charset="0"/>
-              </a:rPr>
-              <a:t>Random </a:t>
-            </a:r>
-            <a:r>
-              <a:rPr lang="en-IN" sz="2000" b="1" dirty="0">
-                <a:latin typeface="Times New Roman" panose="02020603050405020304" pitchFamily="18" charset="0"/>
-                <a:cs typeface="Times New Roman" panose="02020603050405020304" pitchFamily="18" charset="0"/>
-              </a:rPr>
-              <a:t>Forest Regression </a:t>
-            </a:r>
-            <a:r>
-              <a:rPr lang="en-IN" sz="2000" dirty="0">
-                <a:latin typeface="Times New Roman" panose="02020603050405020304" pitchFamily="18" charset="0"/>
-                <a:cs typeface="Times New Roman" panose="02020603050405020304" pitchFamily="18" charset="0"/>
-              </a:rPr>
-              <a:t>is a supervised learning algorithm that uses ensemble learning method for regression. Ensemble learning method is a technique that combines predictions from multiple machine learning algorithms to make a more accurate prediction than a single model.</a:t>
+              <a:t>Three regression models are implemented and compared: Linear Regression (baseline), Ridge Regression (L2 regularization, alpha selected by 5-fold CV) and Random Forest (200 trees, min_samples_leaf = 3, chosen by a 5-fold CV grid search). All models predict log(1 + price); predictions are inverted back to Lakh INR for scoring and display.</a:t>
             </a:r>
           </a:p>
         </p:txBody>
@@ -8021,18 +7768,10 @@
           <a:p>
             <a:pPr algn="ctr"/>
             <a:r>
-              <a:rPr lang="en-US" b="1" dirty="0" smtClean="0">
-                <a:effectLst>
-                  <a:outerShdw blurRad="38100" dist="38100" dir="2700000" algn="tl">
-                    <a:srgbClr val="000000">
-                      <a:alpha val="43137"/>
-                    </a:srgbClr>
-                  </a:outerShdw>
-                </a:effectLst>
-                <a:latin typeface="Times New Roman" panose="02020603050405020304" pitchFamily="18" charset="0"/>
-                <a:cs typeface="Times New Roman" panose="02020603050405020304" pitchFamily="18" charset="0"/>
+              <a:rPr b="1">
+                <a:latin typeface="Times New Roman"/>
               </a:rPr>
-              <a:t>CLASSIFICATION</a:t>
+              <a:t>MODEL TRAINING</a:t>
             </a:r>
             <a:endParaRPr lang="en-IN" b="1" dirty="0">
               <a:effectLst>
@@ -8089,20 +7828,22 @@
       </p:sp>
       <p:pic>
         <p:nvPicPr>
-          <p:cNvPr id="7" name="Picture 6"/>
-          <p:cNvPicPr/>
+          <p:cNvPr id="9" name="Picture 8" descr="r2_bars.png"/>
+          <p:cNvPicPr>
+            <a:picLocks noChangeAspect="1"/>
+          </p:cNvPicPr>
           <p:nvPr/>
         </p:nvPicPr>
         <p:blipFill>
-          <a:blip r:embed="rId2"/>
+          <a:blip r:embed="rId4"/>
           <a:stretch>
             <a:fillRect/>
           </a:stretch>
         </p:blipFill>
         <p:spPr>
           <a:xfrm>
-            <a:off x="3331335" y="1867504"/>
-            <a:ext cx="5233116" cy="1107516"/>
+            <a:off x="3291840" y="1828800"/>
+            <a:ext cx="5212080" cy="1212112"/>
           </a:xfrm>
           <a:prstGeom prst="rect">
             <a:avLst/>
@@ -8111,20 +7852,22 @@
       </p:pic>
       <p:pic>
         <p:nvPicPr>
-          <p:cNvPr id="8" name="Picture 7"/>
-          <p:cNvPicPr/>
+          <p:cNvPr id="10" name="Picture 9" descr="mae_bars.png"/>
+          <p:cNvPicPr>
+            <a:picLocks noChangeAspect="1"/>
+          </p:cNvPicPr>
           <p:nvPr/>
         </p:nvPicPr>
         <p:blipFill>
-          <a:blip r:embed="rId3"/>
+          <a:blip r:embed="rId5"/>
           <a:stretch>
             <a:fillRect/>
           </a:stretch>
         </p:blipFill>
         <p:spPr>
           <a:xfrm>
-            <a:off x="3331335" y="3834339"/>
-            <a:ext cx="5233116" cy="1111147"/>
+            <a:off x="3291840" y="3840480"/>
+            <a:ext cx="5212080" cy="1212112"/>
           </a:xfrm>
           <a:prstGeom prst="rect">
             <a:avLst/>
@@ -8233,56 +7976,11 @@
               </a:lnSpc>
             </a:pPr>
             <a:r>
-              <a:rPr lang="en-US" dirty="0"/>
-              <a:t>The accurate prediction of house prices is of paramount importance in real estate and property markets. In recent years, machine learning algorithms have emerged as powerful tools for addressing this challenge. </a:t>
-            </a:r>
-            <a:r>
-              <a:rPr lang="en-IN" sz="2000" dirty="0" smtClean="0">
-                <a:latin typeface="Times New Roman" panose="02020603050405020304" pitchFamily="18" charset="0"/>
-                <a:cs typeface="Times New Roman" panose="02020603050405020304" pitchFamily="18" charset="0"/>
+              <a:rPr sz="2000">
+                <a:latin typeface="+mn-lt"/>
               </a:rPr>
-              <a:t>. </a:t>
-            </a:r>
-          </a:p>
-          <a:p>
-            <a:pPr>
-              <a:lnSpc>
-                <a:spcPct val="150000"/>
-              </a:lnSpc>
-            </a:pPr>
-            <a:r>
-              <a:rPr lang="en-US" dirty="0"/>
-              <a:t>The study begins by gathering a comprehensive dataset comprising a wide range of factors that influence house prices, such as location, size, number of bedrooms, bathrooms, amenities, and socio-economic indicators</a:t>
-            </a:r>
-            <a:r>
-              <a:rPr lang="en-US" dirty="0" smtClean="0"/>
-              <a:t>.</a:t>
-            </a:r>
-          </a:p>
-          <a:p>
-            <a:pPr>
-              <a:lnSpc>
-                <a:spcPct val="150000"/>
-              </a:lnSpc>
-            </a:pPr>
-            <a:r>
-              <a:rPr lang="en-IN" sz="2000" dirty="0" smtClean="0">
-                <a:latin typeface="+mn-lt"/>
-                <a:cs typeface="Times New Roman" panose="02020603050405020304" pitchFamily="18" charset="0"/>
-              </a:rPr>
-              <a:t>We </a:t>
-            </a:r>
-            <a:r>
-              <a:rPr lang="en-IN" sz="2000" dirty="0">
-                <a:latin typeface="+mn-lt"/>
-                <a:cs typeface="Times New Roman" panose="02020603050405020304" pitchFamily="18" charset="0"/>
-              </a:rPr>
-              <a:t>have to implement the regression technique to predict the housing price such as Ridge and random forest regression. Finally, the experimental results shows that the error values, estimate the house price in Lakhs. </a:t>
-            </a:r>
-            <a:endParaRPr lang="en-IN" sz="2000" dirty="0" smtClean="0">
-              <a:latin typeface="+mn-lt"/>
-              <a:cs typeface="Times New Roman" panose="02020603050405020304" pitchFamily="18" charset="0"/>
-            </a:endParaRPr>
+              <a:t>House prices in Bengaluru depend on location, size, area and society in ways that are difficult to capture manually. In this project, the price of a house is predicted from its basic details using three regression models - Linear Regression, Ridge Regression and Random Forest - trained on 13,320 historical listings collected from Kaggle. The raw data is cleaned (area-unit conversion, removal of impossible rows), features are engineered (BHK count, completion year, frequency-encoded location and society), and the models are evaluated with a 70/30 holdout plus 5-fold cross validation on a log-price target. The tuned Random Forest explains 79% of the (log) price variation and is selected as the best model. The results are delivered through a Streamlit app, a custom FastAPI web UI and a REST API with Docker deployment.</a:t>
+            </a:r>
           </a:p>
         </p:txBody>
       </p:sp>
@@ -8454,20 +8152,22 @@
       </p:sp>
       <p:pic>
         <p:nvPicPr>
-          <p:cNvPr id="6" name="Picture 5"/>
-          <p:cNvPicPr/>
+          <p:cNvPr id="5" name="Picture 4" descr="sample_predictions.png"/>
+          <p:cNvPicPr>
+            <a:picLocks noChangeAspect="1"/>
+          </p:cNvPicPr>
           <p:nvPr/>
         </p:nvPicPr>
         <p:blipFill>
-          <a:blip r:embed="rId2"/>
+          <a:blip r:embed="rId3"/>
           <a:stretch>
             <a:fillRect/>
           </a:stretch>
         </p:blipFill>
         <p:spPr>
           <a:xfrm>
-            <a:off x="3773511" y="1738649"/>
-            <a:ext cx="4587804" cy="4230352"/>
+            <a:off x="3749039" y="2528840"/>
+            <a:ext cx="4572000" cy="2623279"/>
           </a:xfrm>
           <a:prstGeom prst="rect">
             <a:avLst/>
@@ -8590,239 +8290,11 @@
               </a:lnSpc>
             </a:pPr>
             <a:r>
-              <a:rPr lang="en-IN" sz="2000" dirty="0">
-                <a:latin typeface="Times New Roman" panose="02020603050405020304" pitchFamily="18" charset="0"/>
-                <a:cs typeface="Times New Roman" panose="02020603050405020304" pitchFamily="18" charset="0"/>
+              <a:rPr sz="2000">
+                <a:latin typeface="Times New Roman"/>
               </a:rPr>
-              <a:t>The Final Result will get generated based on the overall classification and prediction. The performance of this proposed approach is evaluated using some measures </a:t>
-            </a:r>
-            <a:r>
-              <a:rPr lang="en-IN" sz="2000" dirty="0" smtClean="0">
-                <a:latin typeface="Times New Roman" panose="02020603050405020304" pitchFamily="18" charset="0"/>
-                <a:cs typeface="Times New Roman" panose="02020603050405020304" pitchFamily="18" charset="0"/>
-              </a:rPr>
-              <a:t>like,</a:t>
-            </a:r>
-          </a:p>
-          <a:p>
-            <a:pPr algn="just">
-              <a:lnSpc>
-                <a:spcPct val="150000"/>
-              </a:lnSpc>
-            </a:pPr>
-            <a:r>
-              <a:rPr lang="en-IN" sz="2000" b="1" dirty="0" smtClean="0">
-                <a:latin typeface="Times New Roman" panose="02020603050405020304" pitchFamily="18" charset="0"/>
-                <a:cs typeface="Times New Roman" panose="02020603050405020304" pitchFamily="18" charset="0"/>
-              </a:rPr>
-              <a:t>MAE</a:t>
-            </a:r>
-            <a:r>
-              <a:rPr lang="en-IN" sz="2000" b="1" dirty="0">
-                <a:latin typeface="Times New Roman" panose="02020603050405020304" pitchFamily="18" charset="0"/>
-                <a:cs typeface="Times New Roman" panose="02020603050405020304" pitchFamily="18" charset="0"/>
-              </a:rPr>
-              <a:t>: </a:t>
-            </a:r>
-            <a:r>
-              <a:rPr lang="en-IN" sz="2000" dirty="0">
-                <a:latin typeface="Times New Roman" panose="02020603050405020304" pitchFamily="18" charset="0"/>
-                <a:cs typeface="Times New Roman" panose="02020603050405020304" pitchFamily="18" charset="0"/>
-              </a:rPr>
-              <a:t>In statistics, the mean absolute error (MAE) is a way to measure the accuracy of a given model. It is calculated </a:t>
-            </a:r>
-            <a:r>
-              <a:rPr lang="en-IN" sz="2000" dirty="0" smtClean="0">
-                <a:latin typeface="Times New Roman" panose="02020603050405020304" pitchFamily="18" charset="0"/>
-                <a:cs typeface="Times New Roman" panose="02020603050405020304" pitchFamily="18" charset="0"/>
-              </a:rPr>
-              <a:t>as</a:t>
-            </a:r>
-            <a:r>
-              <a:rPr lang="en-IN" sz="2000" dirty="0" smtClean="0">
-                <a:latin typeface="Times New Roman" panose="02020603050405020304" pitchFamily="18" charset="0"/>
-                <a:cs typeface="Times New Roman" panose="02020603050405020304" pitchFamily="18" charset="0"/>
-              </a:rPr>
-              <a:t>, </a:t>
-            </a:r>
-            <a:r>
-              <a:rPr lang="en-IN" b="1" dirty="0">
-                <a:latin typeface="Times New Roman" panose="02020603050405020304" pitchFamily="18" charset="0"/>
-                <a:ea typeface="Times New Roman" panose="02020603050405020304" pitchFamily="18" charset="0"/>
-                <a:cs typeface="Times New Roman" panose="02020603050405020304" pitchFamily="18" charset="0"/>
-              </a:rPr>
-              <a:t>MAE = (1/n) * </a:t>
-            </a:r>
-            <a:r>
-              <a:rPr lang="en-IN" b="1" dirty="0" err="1">
-                <a:latin typeface="Times New Roman" panose="02020603050405020304" pitchFamily="18" charset="0"/>
-                <a:ea typeface="Times New Roman" panose="02020603050405020304" pitchFamily="18" charset="0"/>
-                <a:cs typeface="Times New Roman" panose="02020603050405020304" pitchFamily="18" charset="0"/>
-              </a:rPr>
-              <a:t>Σ|y</a:t>
-            </a:r>
-            <a:r>
-              <a:rPr lang="en-IN" b="1" baseline="-25000" dirty="0" err="1">
-                <a:latin typeface="Times New Roman" panose="02020603050405020304" pitchFamily="18" charset="0"/>
-                <a:ea typeface="Times New Roman" panose="02020603050405020304" pitchFamily="18" charset="0"/>
-                <a:cs typeface="Times New Roman" panose="02020603050405020304" pitchFamily="18" charset="0"/>
-              </a:rPr>
-              <a:t>i</a:t>
-            </a:r>
-            <a:r>
-              <a:rPr lang="en-IN" b="1" dirty="0">
-                <a:latin typeface="Times New Roman" panose="02020603050405020304" pitchFamily="18" charset="0"/>
-                <a:ea typeface="Times New Roman" panose="02020603050405020304" pitchFamily="18" charset="0"/>
-                <a:cs typeface="Times New Roman" panose="02020603050405020304" pitchFamily="18" charset="0"/>
-              </a:rPr>
-              <a:t> – x</a:t>
-            </a:r>
-            <a:r>
-              <a:rPr lang="en-IN" b="1" baseline="-25000" dirty="0">
-                <a:latin typeface="Times New Roman" panose="02020603050405020304" pitchFamily="18" charset="0"/>
-                <a:ea typeface="Times New Roman" panose="02020603050405020304" pitchFamily="18" charset="0"/>
-                <a:cs typeface="Times New Roman" panose="02020603050405020304" pitchFamily="18" charset="0"/>
-              </a:rPr>
-              <a:t>i</a:t>
-            </a:r>
-            <a:r>
-              <a:rPr lang="en-IN" b="1" dirty="0" smtClean="0">
-                <a:latin typeface="Times New Roman" panose="02020603050405020304" pitchFamily="18" charset="0"/>
-                <a:ea typeface="Times New Roman" panose="02020603050405020304" pitchFamily="18" charset="0"/>
-                <a:cs typeface="Times New Roman" panose="02020603050405020304" pitchFamily="18" charset="0"/>
-              </a:rPr>
-              <a:t>|</a:t>
-            </a:r>
-            <a:endParaRPr lang="en-IN" sz="2000" dirty="0" smtClean="0">
-              <a:latin typeface="Times New Roman" panose="02020603050405020304" pitchFamily="18" charset="0"/>
-              <a:cs typeface="Times New Roman" panose="02020603050405020304" pitchFamily="18" charset="0"/>
-            </a:endParaRPr>
-          </a:p>
-          <a:p>
-            <a:pPr lvl="0" algn="just">
-              <a:lnSpc>
-                <a:spcPct val="150000"/>
-              </a:lnSpc>
-              <a:buFont typeface="Courier New" panose="02070309020205020404" pitchFamily="49" charset="0"/>
-              <a:buChar char="o"/>
-            </a:pPr>
-            <a:r>
-              <a:rPr lang="en-IN" sz="2000" dirty="0" smtClean="0">
-                <a:latin typeface="Times New Roman" panose="02020603050405020304" pitchFamily="18" charset="0"/>
-                <a:cs typeface="Times New Roman" panose="02020603050405020304" pitchFamily="18" charset="0"/>
-              </a:rPr>
-              <a:t>•	Σ: </a:t>
-            </a:r>
-            <a:r>
-              <a:rPr lang="en-IN" sz="2000" dirty="0">
-                <a:latin typeface="Times New Roman" panose="02020603050405020304" pitchFamily="18" charset="0"/>
-                <a:cs typeface="Times New Roman" panose="02020603050405020304" pitchFamily="18" charset="0"/>
-              </a:rPr>
-              <a:t>A Greek symbol that means “sum”</a:t>
-            </a:r>
-          </a:p>
-          <a:p>
-            <a:pPr lvl="0" algn="just">
-              <a:lnSpc>
-                <a:spcPct val="150000"/>
-              </a:lnSpc>
-              <a:buFont typeface="Courier New" panose="02070309020205020404" pitchFamily="49" charset="0"/>
-              <a:buChar char="o"/>
-            </a:pPr>
-            <a:r>
-              <a:rPr lang="en-IN" sz="2000" dirty="0">
-                <a:latin typeface="Times New Roman" panose="02020603050405020304" pitchFamily="18" charset="0"/>
-                <a:cs typeface="Times New Roman" panose="02020603050405020304" pitchFamily="18" charset="0"/>
-              </a:rPr>
-              <a:t>•	</a:t>
-            </a:r>
-            <a:r>
-              <a:rPr lang="en-IN" sz="2000" dirty="0" err="1">
-                <a:latin typeface="Times New Roman" panose="02020603050405020304" pitchFamily="18" charset="0"/>
-                <a:cs typeface="Times New Roman" panose="02020603050405020304" pitchFamily="18" charset="0"/>
-              </a:rPr>
-              <a:t>yi</a:t>
-            </a:r>
-            <a:r>
-              <a:rPr lang="en-IN" sz="2000" dirty="0">
-                <a:latin typeface="Times New Roman" panose="02020603050405020304" pitchFamily="18" charset="0"/>
-                <a:cs typeface="Times New Roman" panose="02020603050405020304" pitchFamily="18" charset="0"/>
-              </a:rPr>
-              <a:t>: The observed value for the </a:t>
-            </a:r>
-            <a:r>
-              <a:rPr lang="en-IN" sz="2000" dirty="0" err="1">
-                <a:latin typeface="Times New Roman" panose="02020603050405020304" pitchFamily="18" charset="0"/>
-                <a:cs typeface="Times New Roman" panose="02020603050405020304" pitchFamily="18" charset="0"/>
-              </a:rPr>
-              <a:t>ith</a:t>
-            </a:r>
-            <a:r>
-              <a:rPr lang="en-IN" sz="2000" dirty="0">
-                <a:latin typeface="Times New Roman" panose="02020603050405020304" pitchFamily="18" charset="0"/>
-                <a:cs typeface="Times New Roman" panose="02020603050405020304" pitchFamily="18" charset="0"/>
-              </a:rPr>
-              <a:t> observation</a:t>
-            </a:r>
-          </a:p>
-          <a:p>
-            <a:pPr lvl="0" algn="just">
-              <a:lnSpc>
-                <a:spcPct val="150000"/>
-              </a:lnSpc>
-              <a:buFont typeface="Courier New" panose="02070309020205020404" pitchFamily="49" charset="0"/>
-              <a:buChar char="o"/>
-            </a:pPr>
-            <a:r>
-              <a:rPr lang="en-IN" sz="2000" dirty="0">
-                <a:latin typeface="Times New Roman" panose="02020603050405020304" pitchFamily="18" charset="0"/>
-                <a:cs typeface="Times New Roman" panose="02020603050405020304" pitchFamily="18" charset="0"/>
-              </a:rPr>
-              <a:t>•	xi: The predicted value for the </a:t>
-            </a:r>
-            <a:r>
-              <a:rPr lang="en-IN" sz="2000" dirty="0" err="1">
-                <a:latin typeface="Times New Roman" panose="02020603050405020304" pitchFamily="18" charset="0"/>
-                <a:cs typeface="Times New Roman" panose="02020603050405020304" pitchFamily="18" charset="0"/>
-              </a:rPr>
-              <a:t>ith</a:t>
-            </a:r>
-            <a:r>
-              <a:rPr lang="en-IN" sz="2000" dirty="0">
-                <a:latin typeface="Times New Roman" panose="02020603050405020304" pitchFamily="18" charset="0"/>
-                <a:cs typeface="Times New Roman" panose="02020603050405020304" pitchFamily="18" charset="0"/>
-              </a:rPr>
-              <a:t> observation</a:t>
-            </a:r>
-          </a:p>
-          <a:p>
-            <a:pPr lvl="0" algn="just">
-              <a:lnSpc>
-                <a:spcPct val="150000"/>
-              </a:lnSpc>
-              <a:buFont typeface="Courier New" panose="02070309020205020404" pitchFamily="49" charset="0"/>
-              <a:buChar char="o"/>
-            </a:pPr>
-            <a:r>
-              <a:rPr lang="en-IN" sz="2000" dirty="0">
-                <a:latin typeface="Times New Roman" panose="02020603050405020304" pitchFamily="18" charset="0"/>
-                <a:cs typeface="Times New Roman" panose="02020603050405020304" pitchFamily="18" charset="0"/>
-              </a:rPr>
-              <a:t>•	n: The total number of observations</a:t>
-            </a:r>
-          </a:p>
-          <a:p>
-            <a:pPr lvl="0" algn="just">
-              <a:lnSpc>
-                <a:spcPct val="150000"/>
-              </a:lnSpc>
-              <a:buFont typeface="Courier New" panose="02070309020205020404" pitchFamily="49" charset="0"/>
-              <a:buChar char="o"/>
-            </a:pPr>
-            <a:endParaRPr lang="en-IN" sz="2000" dirty="0">
-              <a:latin typeface="Times New Roman" panose="02020603050405020304" pitchFamily="18" charset="0"/>
-              <a:cs typeface="Times New Roman" panose="02020603050405020304" pitchFamily="18" charset="0"/>
-            </a:endParaRPr>
+              <a:t>The final results on the held-out test set (3,979 rows): Random Forest - R2 0.787, MAE 0.231 (log), MAE 31.4 Lakh, RMSE 89.4 Lakh; both linear models - R2 0.644, MAE 44.8 Lakh. The Random Forest's 5-fold CV R2 (0.776) matches its test score, so it generalizes rather than memorizes. An MAE (log) of 0.231 means the typical prediction is within about a quarter (multiplicatively) of the actual price; the Lakh-scale MAE is inflated by a few very expensive listings.</a:t>
+            </a:r>
           </a:p>
         </p:txBody>
       </p:sp>
@@ -8962,62 +8434,15 @@
               </a:lnSpc>
             </a:pPr>
             <a:r>
-              <a:rPr lang="en-IN" sz="2000" dirty="0">
-                <a:latin typeface="Times New Roman" panose="02020603050405020304" pitchFamily="18" charset="0"/>
-                <a:cs typeface="Times New Roman" panose="02020603050405020304" pitchFamily="18" charset="0"/>
+              <a:rPr sz="2000">
+                <a:latin typeface="Times New Roman"/>
               </a:rPr>
-              <a:t>We conclude that, the house price dataset was taken as input. The input dataset was mentioned in our research paper. </a:t>
+              <a:t>We conclude that house prices in Bengaluru can be predicted from basic property details using regression models. Data cleaning and feature engineering - unit conversion, BHK/year derivation, frequency encoding and the log-price target - matter more than the algorithm choice, and the tuned Random Forest is the best model (R2 0.787, MAE 0.231 log). The trained models are delivered through a Streamlit app, a custom FastAPI web UI and a REST API, packaged in Docker with automated tests and CI. The predictions are estimates on historical listings, not current market quotes.</a:t>
             </a:r>
             <a:endParaRPr lang="en-IN" sz="2000" dirty="0" smtClean="0">
               <a:latin typeface="Times New Roman" panose="02020603050405020304" pitchFamily="18" charset="0"/>
               <a:cs typeface="Times New Roman" panose="02020603050405020304" pitchFamily="18" charset="0"/>
             </a:endParaRPr>
-          </a:p>
-          <a:p>
-            <a:pPr algn="just">
-              <a:lnSpc>
-                <a:spcPct val="150000"/>
-              </a:lnSpc>
-            </a:pPr>
-            <a:r>
-              <a:rPr lang="en-IN" sz="2000" dirty="0" smtClean="0">
-                <a:latin typeface="Times New Roman" panose="02020603050405020304" pitchFamily="18" charset="0"/>
-                <a:cs typeface="Times New Roman" panose="02020603050405020304" pitchFamily="18" charset="0"/>
-              </a:rPr>
-              <a:t>We </a:t>
-            </a:r>
-            <a:r>
-              <a:rPr lang="en-IN" sz="2000" dirty="0">
-                <a:latin typeface="Times New Roman" panose="02020603050405020304" pitchFamily="18" charset="0"/>
-                <a:cs typeface="Times New Roman" panose="02020603050405020304" pitchFamily="18" charset="0"/>
-              </a:rPr>
-              <a:t>are implemented the different machine algorithm such as random forest regression and ridge regression. </a:t>
-            </a:r>
-            <a:endParaRPr lang="en-IN" sz="2000" dirty="0" smtClean="0">
-              <a:latin typeface="Times New Roman" panose="02020603050405020304" pitchFamily="18" charset="0"/>
-              <a:cs typeface="Times New Roman" panose="02020603050405020304" pitchFamily="18" charset="0"/>
-            </a:endParaRPr>
-          </a:p>
-          <a:p>
-            <a:pPr algn="just">
-              <a:lnSpc>
-                <a:spcPct val="150000"/>
-              </a:lnSpc>
-            </a:pPr>
-            <a:r>
-              <a:rPr lang="en-IN" sz="2000" dirty="0" smtClean="0">
-                <a:latin typeface="Times New Roman" panose="02020603050405020304" pitchFamily="18" charset="0"/>
-                <a:cs typeface="Times New Roman" panose="02020603050405020304" pitchFamily="18" charset="0"/>
-              </a:rPr>
-              <a:t>Then</a:t>
-            </a:r>
-            <a:r>
-              <a:rPr lang="en-IN" sz="2000" dirty="0">
-                <a:latin typeface="Times New Roman" panose="02020603050405020304" pitchFamily="18" charset="0"/>
-                <a:cs typeface="Times New Roman" panose="02020603050405020304" pitchFamily="18" charset="0"/>
-              </a:rPr>
-              <a:t>, we are predicted the house price and performance metrics such as MAE.</a:t>
-            </a:r>
           </a:p>
         </p:txBody>
       </p:sp>
@@ -9153,39 +8578,10 @@
               <a:buNone/>
             </a:pPr>
             <a:r>
-              <a:rPr lang="en-US" sz="2000" dirty="0">
-                <a:latin typeface="Times New Roman" panose="02020603050405020304" pitchFamily="18" charset="0"/>
-                <a:cs typeface="Times New Roman" panose="02020603050405020304" pitchFamily="18" charset="0"/>
+              <a:rPr sz="2000">
+                <a:latin typeface="Times New Roman"/>
               </a:rPr>
-              <a:t>[1] </a:t>
-            </a:r>
-            <a:r>
-              <a:rPr lang="en-US" sz="2000" dirty="0" err="1">
-                <a:latin typeface="Times New Roman" panose="02020603050405020304" pitchFamily="18" charset="0"/>
-                <a:cs typeface="Times New Roman" panose="02020603050405020304" pitchFamily="18" charset="0"/>
-              </a:rPr>
-              <a:t>Jiawei</a:t>
-            </a:r>
-            <a:r>
-              <a:rPr lang="en-US" sz="2000" dirty="0">
-                <a:latin typeface="Times New Roman" panose="02020603050405020304" pitchFamily="18" charset="0"/>
-                <a:cs typeface="Times New Roman" panose="02020603050405020304" pitchFamily="18" charset="0"/>
-              </a:rPr>
-              <a:t> Han, </a:t>
-            </a:r>
-            <a:r>
-              <a:rPr lang="en-US" sz="2000" dirty="0" err="1">
-                <a:latin typeface="Times New Roman" panose="02020603050405020304" pitchFamily="18" charset="0"/>
-                <a:cs typeface="Times New Roman" panose="02020603050405020304" pitchFamily="18" charset="0"/>
-              </a:rPr>
-              <a:t>MichelineKamber</a:t>
-            </a:r>
-            <a:r>
-              <a:rPr lang="en-US" sz="2000" dirty="0">
-                <a:latin typeface="Times New Roman" panose="02020603050405020304" pitchFamily="18" charset="0"/>
-                <a:cs typeface="Times New Roman" panose="02020603050405020304" pitchFamily="18" charset="0"/>
-              </a:rPr>
-              <a:t>, “Data Mining Concepts and Techniques”, pp. 279-328, 2001. </a:t>
+              <a:t>[1] Kaggle - Bengaluru House price data. https://www.kaggle.com/amitabhajoy/bengaluru-house-price-data (CC0).</a:t>
             </a:r>
           </a:p>
           <a:p>
@@ -9196,39 +8592,10 @@
               <a:buNone/>
             </a:pPr>
             <a:r>
-              <a:rPr lang="en-US" sz="2000" dirty="0">
-                <a:latin typeface="Times New Roman" panose="02020603050405020304" pitchFamily="18" charset="0"/>
-                <a:cs typeface="Times New Roman" panose="02020603050405020304" pitchFamily="18" charset="0"/>
+              <a:rPr sz="2000">
+                <a:latin typeface="Times New Roman"/>
               </a:rPr>
-              <a:t>[2] J. </a:t>
-            </a:r>
-            <a:r>
-              <a:rPr lang="en-US" sz="2000" dirty="0" err="1">
-                <a:latin typeface="Times New Roman" panose="02020603050405020304" pitchFamily="18" charset="0"/>
-                <a:cs typeface="Times New Roman" panose="02020603050405020304" pitchFamily="18" charset="0"/>
-              </a:rPr>
-              <a:t>R.Quinlan</a:t>
-            </a:r>
-            <a:r>
-              <a:rPr lang="en-US" sz="2000" dirty="0">
-                <a:latin typeface="Times New Roman" panose="02020603050405020304" pitchFamily="18" charset="0"/>
-                <a:cs typeface="Times New Roman" panose="02020603050405020304" pitchFamily="18" charset="0"/>
-              </a:rPr>
-              <a:t>,” Simplifying decision trees”, Int. J. </a:t>
-            </a:r>
-            <a:r>
-              <a:rPr lang="en-US" sz="2000" dirty="0" err="1">
-                <a:latin typeface="Times New Roman" panose="02020603050405020304" pitchFamily="18" charset="0"/>
-                <a:cs typeface="Times New Roman" panose="02020603050405020304" pitchFamily="18" charset="0"/>
-              </a:rPr>
-              <a:t>HumanComputer</a:t>
-            </a:r>
-            <a:r>
-              <a:rPr lang="en-US" sz="2000" dirty="0">
-                <a:latin typeface="Times New Roman" panose="02020603050405020304" pitchFamily="18" charset="0"/>
-                <a:cs typeface="Times New Roman" panose="02020603050405020304" pitchFamily="18" charset="0"/>
-              </a:rPr>
-              <a:t> Studies. </a:t>
+              <a:t>[2] scikit-learn documentation. https://scikit-learn.org</a:t>
             </a:r>
           </a:p>
           <a:p>
@@ -9239,53 +8606,10 @@
               <a:buNone/>
             </a:pPr>
             <a:r>
-              <a:rPr lang="en-US" sz="2000" dirty="0">
-                <a:latin typeface="Times New Roman" panose="02020603050405020304" pitchFamily="18" charset="0"/>
-                <a:cs typeface="Times New Roman" panose="02020603050405020304" pitchFamily="18" charset="0"/>
+              <a:rPr sz="2000">
+                <a:latin typeface="Times New Roman"/>
               </a:rPr>
-              <a:t>[3] Maria-</a:t>
-            </a:r>
-            <a:r>
-              <a:rPr lang="en-US" sz="2000" dirty="0" err="1">
-                <a:latin typeface="Times New Roman" panose="02020603050405020304" pitchFamily="18" charset="0"/>
-                <a:cs typeface="Times New Roman" panose="02020603050405020304" pitchFamily="18" charset="0"/>
-              </a:rPr>
-              <a:t>Luiza</a:t>
-            </a:r>
-            <a:r>
-              <a:rPr lang="en-US" sz="2000" dirty="0">
-                <a:latin typeface="Times New Roman" panose="02020603050405020304" pitchFamily="18" charset="0"/>
-                <a:cs typeface="Times New Roman" panose="02020603050405020304" pitchFamily="18" charset="0"/>
-              </a:rPr>
-              <a:t> </a:t>
-            </a:r>
-            <a:r>
-              <a:rPr lang="en-US" sz="2000" dirty="0" err="1">
-                <a:latin typeface="Times New Roman" panose="02020603050405020304" pitchFamily="18" charset="0"/>
-                <a:cs typeface="Times New Roman" panose="02020603050405020304" pitchFamily="18" charset="0"/>
-              </a:rPr>
-              <a:t>Antonie</a:t>
-            </a:r>
-            <a:r>
-              <a:rPr lang="en-US" sz="2000" dirty="0">
-                <a:latin typeface="Times New Roman" panose="02020603050405020304" pitchFamily="18" charset="0"/>
-                <a:cs typeface="Times New Roman" panose="02020603050405020304" pitchFamily="18" charset="0"/>
-              </a:rPr>
-              <a:t>, et. al., “Application of Data Mining Techniques for Medical Image Classification”, Proceedings of the Second International Workshop on multimedia Data Mining(MDM/KDD’2001) in conjunction with ACM SIGKDD conference. San </a:t>
-            </a:r>
-            <a:r>
-              <a:rPr lang="en-US" sz="2000" dirty="0" err="1">
-                <a:latin typeface="Times New Roman" panose="02020603050405020304" pitchFamily="18" charset="0"/>
-                <a:cs typeface="Times New Roman" panose="02020603050405020304" pitchFamily="18" charset="0"/>
-              </a:rPr>
-              <a:t>Francisco,USA</a:t>
-            </a:r>
-            <a:r>
-              <a:rPr lang="en-US" sz="2000" dirty="0">
-                <a:latin typeface="Times New Roman" panose="02020603050405020304" pitchFamily="18" charset="0"/>
-                <a:cs typeface="Times New Roman" panose="02020603050405020304" pitchFamily="18" charset="0"/>
-              </a:rPr>
-              <a:t>, August 26,2001.</a:t>
+              <a:t>[3] Streamlit documentation. https://docs.streamlit.io</a:t>
             </a:r>
           </a:p>
           <a:p>
@@ -9296,53 +8620,10 @@
               <a:buNone/>
             </a:pPr>
             <a:r>
-              <a:rPr lang="en-US" sz="2000" dirty="0">
-                <a:latin typeface="Times New Roman" panose="02020603050405020304" pitchFamily="18" charset="0"/>
-                <a:cs typeface="Times New Roman" panose="02020603050405020304" pitchFamily="18" charset="0"/>
+              <a:rPr sz="2000">
+                <a:latin typeface="Times New Roman"/>
               </a:rPr>
-              <a:t> [4] Nikita Patel and </a:t>
-            </a:r>
-            <a:r>
-              <a:rPr lang="en-US" sz="2000" dirty="0" err="1">
-                <a:latin typeface="Times New Roman" panose="02020603050405020304" pitchFamily="18" charset="0"/>
-                <a:cs typeface="Times New Roman" panose="02020603050405020304" pitchFamily="18" charset="0"/>
-              </a:rPr>
-              <a:t>Saurabh</a:t>
-            </a:r>
-            <a:r>
-              <a:rPr lang="en-US" sz="2000" dirty="0">
-                <a:latin typeface="Times New Roman" panose="02020603050405020304" pitchFamily="18" charset="0"/>
-                <a:cs typeface="Times New Roman" panose="02020603050405020304" pitchFamily="18" charset="0"/>
-              </a:rPr>
-              <a:t> </a:t>
-            </a:r>
-            <a:r>
-              <a:rPr lang="en-US" sz="2000" dirty="0" err="1">
-                <a:latin typeface="Times New Roman" panose="02020603050405020304" pitchFamily="18" charset="0"/>
-                <a:cs typeface="Times New Roman" panose="02020603050405020304" pitchFamily="18" charset="0"/>
-              </a:rPr>
-              <a:t>Upadhyay</a:t>
-            </a:r>
-            <a:r>
-              <a:rPr lang="en-US" sz="2000" dirty="0">
-                <a:latin typeface="Times New Roman" panose="02020603050405020304" pitchFamily="18" charset="0"/>
-                <a:cs typeface="Times New Roman" panose="02020603050405020304" pitchFamily="18" charset="0"/>
-              </a:rPr>
-              <a:t>, “Study of Various Decision Tree Pruning Methods with their Empirical Comparison in WEKA”, International Journal of Computer Applications, Volume 60– No.12, December 2012, </a:t>
-            </a:r>
-            <a:r>
-              <a:rPr lang="en-US" sz="2000" dirty="0" err="1">
-                <a:latin typeface="Times New Roman" panose="02020603050405020304" pitchFamily="18" charset="0"/>
-                <a:cs typeface="Times New Roman" panose="02020603050405020304" pitchFamily="18" charset="0"/>
-              </a:rPr>
-              <a:t>pp</a:t>
-            </a:r>
-            <a:r>
-              <a:rPr lang="en-US" sz="2000" dirty="0">
-                <a:latin typeface="Times New Roman" panose="02020603050405020304" pitchFamily="18" charset="0"/>
-                <a:cs typeface="Times New Roman" panose="02020603050405020304" pitchFamily="18" charset="0"/>
-              </a:rPr>
-              <a:t> 20-25. </a:t>
+              <a:t>[4] FastAPI documentation. https://fastapi.tiangolo.com</a:t>
             </a:r>
           </a:p>
           <a:p>
@@ -9353,24 +8634,25 @@
               <a:buNone/>
             </a:pPr>
             <a:r>
-              <a:rPr lang="en-US" sz="2000" dirty="0">
-                <a:latin typeface="Times New Roman" panose="02020603050405020304" pitchFamily="18" charset="0"/>
-                <a:cs typeface="Times New Roman" panose="02020603050405020304" pitchFamily="18" charset="0"/>
+              <a:rPr sz="2000">
+                <a:latin typeface="Times New Roman"/>
               </a:rPr>
-              <a:t>[5] J.R. Quinlan, “C4.5: programs for Machine Learning”, Morgan Kaufmann, New York, 1993.</a:t>
-            </a:r>
-          </a:p>
-          <a:p>
-            <a:pPr marL="0" indent="0" algn="ctr">
+              <a:t>[5] T. Hastie, R. Tibshirani, J. Friedman, 'The Elements of Statistical Learning', 2nd ed., Springer, 2009.</a:t>
+            </a:r>
+          </a:p>
+          <a:p>
+            <a:pPr marL="0" indent="0" algn="just">
               <a:lnSpc>
-                <a:spcPct val="150000"/>
+                <a:spcPct val="160000"/>
               </a:lnSpc>
               <a:buNone/>
             </a:pPr>
-            <a:endParaRPr lang="en-US" sz="2000" dirty="0">
-              <a:latin typeface="Times New Roman" panose="02020603050405020304" pitchFamily="18" charset="0"/>
-              <a:cs typeface="Times New Roman" panose="02020603050405020304" pitchFamily="18" charset="0"/>
-            </a:endParaRPr>
+            <a:r>
+              <a:rPr sz="2000">
+                <a:latin typeface="Times New Roman"/>
+              </a:rPr>
+              <a:t>[6] J. Han, M. Kamber, J. Pei, 'Data Mining: Concepts and Techniques', 4th ed., Morgan Kaufmann, 2012.</a:t>
+            </a:r>
           </a:p>
         </p:txBody>
       </p:sp>
@@ -9434,175 +8716,6 @@
 </file>
 
 <file path=ppt/slides/slide24.xml><?xml version="1.0" encoding="utf-8"?>
-<p:sld xmlns:a="http://schemas.openxmlformats.org/drawingml/2006/main" xmlns:r="http://schemas.openxmlformats.org/officeDocument/2006/relationships" xmlns:p="http://schemas.openxmlformats.org/presentationml/2006/main">
-  <p:cSld>
-    <p:spTree>
-      <p:nvGrpSpPr>
-        <p:cNvPr id="1" name=""/>
-        <p:cNvGrpSpPr/>
-        <p:nvPr/>
-      </p:nvGrpSpPr>
-      <p:grpSpPr>
-        <a:xfrm>
-          <a:off x="0" y="0"/>
-          <a:ext cx="0" cy="0"/>
-          <a:chOff x="0" y="0"/>
-          <a:chExt cx="0" cy="0"/>
-        </a:xfrm>
-      </p:grpSpPr>
-      <p:sp>
-        <p:nvSpPr>
-          <p:cNvPr id="2" name="Title 1"/>
-          <p:cNvSpPr>
-            <a:spLocks noGrp="1"/>
-          </p:cNvSpPr>
-          <p:nvPr>
-            <p:ph type="title"/>
-          </p:nvPr>
-        </p:nvSpPr>
-        <p:spPr>
-          <a:xfrm>
-            <a:off x="974678" y="2480528"/>
-            <a:ext cx="10515600" cy="1325563"/>
-          </a:xfrm>
-        </p:spPr>
-        <p:txBody>
-          <a:bodyPr>
-            <a:normAutofit/>
-          </a:bodyPr>
-          <a:lstStyle/>
-          <a:p>
-            <a:pPr algn="ctr"/>
-            <a:r>
-              <a:rPr lang="en-US" sz="6000" b="1" i="1" dirty="0" smtClean="0">
-                <a:effectLst>
-                  <a:outerShdw blurRad="38100" dist="38100" dir="2700000" algn="tl">
-                    <a:srgbClr val="000000">
-                      <a:alpha val="43137"/>
-                    </a:srgbClr>
-                  </a:outerShdw>
-                </a:effectLst>
-                <a:latin typeface="Times New Roman" panose="02020603050405020304" pitchFamily="18" charset="0"/>
-                <a:cs typeface="Times New Roman" panose="02020603050405020304" pitchFamily="18" charset="0"/>
-              </a:rPr>
-              <a:t>Thank</a:t>
-            </a:r>
-            <a:r>
-              <a:rPr lang="en-US" sz="6000" b="1" dirty="0" smtClean="0">
-                <a:effectLst>
-                  <a:outerShdw blurRad="38100" dist="38100" dir="2700000" algn="tl">
-                    <a:srgbClr val="000000">
-                      <a:alpha val="43137"/>
-                    </a:srgbClr>
-                  </a:outerShdw>
-                </a:effectLst>
-                <a:latin typeface="Times New Roman" panose="02020603050405020304" pitchFamily="18" charset="0"/>
-                <a:cs typeface="Times New Roman" panose="02020603050405020304" pitchFamily="18" charset="0"/>
-              </a:rPr>
-              <a:t> </a:t>
-            </a:r>
-            <a:r>
-              <a:rPr lang="en-US" sz="6000" b="1" i="1" dirty="0">
-                <a:effectLst>
-                  <a:outerShdw blurRad="38100" dist="38100" dir="2700000" algn="tl">
-                    <a:srgbClr val="000000">
-                      <a:alpha val="43137"/>
-                    </a:srgbClr>
-                  </a:outerShdw>
-                </a:effectLst>
-                <a:latin typeface="Times New Roman" panose="02020603050405020304" pitchFamily="18" charset="0"/>
-                <a:cs typeface="Times New Roman" panose="02020603050405020304" pitchFamily="18" charset="0"/>
-              </a:rPr>
-              <a:t>Y</a:t>
-            </a:r>
-            <a:r>
-              <a:rPr lang="en-US" sz="6000" b="1" i="1" dirty="0" smtClean="0">
-                <a:effectLst>
-                  <a:outerShdw blurRad="38100" dist="38100" dir="2700000" algn="tl">
-                    <a:srgbClr val="000000">
-                      <a:alpha val="43137"/>
-                    </a:srgbClr>
-                  </a:outerShdw>
-                </a:effectLst>
-                <a:latin typeface="Times New Roman" panose="02020603050405020304" pitchFamily="18" charset="0"/>
-                <a:cs typeface="Times New Roman" panose="02020603050405020304" pitchFamily="18" charset="0"/>
-              </a:rPr>
-              <a:t>ou…</a:t>
-            </a:r>
-            <a:endParaRPr lang="en-IN" sz="6000" b="1" i="1" dirty="0">
-              <a:effectLst>
-                <a:outerShdw blurRad="38100" dist="38100" dir="2700000" algn="tl">
-                  <a:srgbClr val="000000">
-                    <a:alpha val="43137"/>
-                  </a:srgbClr>
-                </a:outerShdw>
-              </a:effectLst>
-              <a:latin typeface="Times New Roman" panose="02020603050405020304" pitchFamily="18" charset="0"/>
-              <a:cs typeface="Times New Roman" panose="02020603050405020304" pitchFamily="18" charset="0"/>
-            </a:endParaRPr>
-          </a:p>
-        </p:txBody>
-      </p:sp>
-      <p:sp>
-        <p:nvSpPr>
-          <p:cNvPr id="3" name="Rectangle 2"/>
-          <p:cNvSpPr/>
-          <p:nvPr/>
-        </p:nvSpPr>
-        <p:spPr>
-          <a:xfrm>
-            <a:off x="271463" y="242888"/>
-            <a:ext cx="11658600" cy="6386512"/>
-          </a:xfrm>
-          <a:prstGeom prst="rect">
-            <a:avLst/>
-          </a:prstGeom>
-          <a:noFill/>
-        </p:spPr>
-        <p:style>
-          <a:lnRef idx="2">
-            <a:schemeClr val="dk1"/>
-          </a:lnRef>
-          <a:fillRef idx="1">
-            <a:schemeClr val="lt1"/>
-          </a:fillRef>
-          <a:effectRef idx="0">
-            <a:schemeClr val="dk1"/>
-          </a:effectRef>
-          <a:fontRef idx="minor">
-            <a:schemeClr val="dk1"/>
-          </a:fontRef>
-        </p:style>
-        <p:txBody>
-          <a:bodyPr rtlCol="0" anchor="ctr"/>
-          <a:lstStyle/>
-          <a:p>
-            <a:pPr algn="ctr"/>
-            <a:endParaRPr lang="en-IN"/>
-          </a:p>
-        </p:txBody>
-      </p:sp>
-    </p:spTree>
-    <p:extLst>
-      <p:ext uri="{BB962C8B-B14F-4D97-AF65-F5344CB8AC3E}">
-        <p14:creationId xmlns:p14="http://schemas.microsoft.com/office/powerpoint/2010/main" val="511934383"/>
-      </p:ext>
-    </p:extLst>
-  </p:cSld>
-  <p:clrMapOvr>
-    <a:masterClrMapping/>
-  </p:clrMapOvr>
-  <p:timing>
-    <p:tnLst>
-      <p:par>
-        <p:cTn id="1" dur="indefinite" restart="never" nodeType="tmRoot"/>
-      </p:par>
-    </p:tnLst>
-  </p:timing>
-</p:sld>
-</file>
-
-<file path=ppt/slides/slide25.xml><?xml version="1.0" encoding="utf-8"?>
 <p:sld xmlns:a="http://schemas.openxmlformats.org/drawingml/2006/main" xmlns:p="http://schemas.openxmlformats.org/presentationml/2006/main" xmlns:r="http://schemas.openxmlformats.org/officeDocument/2006/relationships">
   <p:cSld>
     <p:bg>
@@ -10321,6 +9434,195 @@
 </p:sld>
 </file>
 
+<file path=ppt/slides/slide25.xml><?xml version="1.0" encoding="utf-8"?>
+<p:sld xmlns:a="http://schemas.openxmlformats.org/drawingml/2006/main" xmlns:p="http://schemas.openxmlformats.org/presentationml/2006/main" xmlns:r="http://schemas.openxmlformats.org/officeDocument/2006/relationships">
+  <p:cSld>
+    <p:bg>
+      <p:bgPr>
+        <a:solidFill>
+          <a:srgbClr val="0B1020"/>
+        </a:solidFill>
+        <a:effectLst/>
+      </p:bgPr>
+    </p:bg>
+    <p:spTree>
+      <p:nvGrpSpPr>
+        <p:cNvPr id="1" name=""/>
+        <p:cNvGrpSpPr/>
+        <p:nvPr/>
+      </p:nvGrpSpPr>
+      <p:grpSpPr/>
+      <p:sp>
+        <p:nvSpPr>
+          <p:cNvPr id="2" name="TextBox 1"/>
+          <p:cNvSpPr txBox="1"/>
+          <p:nvPr/>
+        </p:nvSpPr>
+        <p:spPr>
+          <a:xfrm>
+            <a:off x="548640" y="320040"/>
+            <a:ext cx="11064240" cy="822960"/>
+          </a:xfrm>
+          <a:prstGeom prst="rect">
+            <a:avLst/>
+          </a:prstGeom>
+          <a:noFill/>
+        </p:spPr>
+        <p:txBody>
+          <a:bodyPr wrap="none">
+            <a:spAutoFit/>
+          </a:bodyPr>
+          <a:lstStyle/>
+          <a:p>
+            <a:pPr>
+              <a:defRPr sz="3000" b="1">
+                <a:solidFill>
+                  <a:srgbClr val="E8ECF8"/>
+                </a:solidFill>
+              </a:defRPr>
+            </a:pPr>
+            <a:r>
+              <a:t>v2 — Data Pipeline Improvements</a:t>
+            </a:r>
+          </a:p>
+        </p:txBody>
+      </p:sp>
+      <p:sp>
+        <p:nvSpPr>
+          <p:cNvPr id="3" name="TextBox 2"/>
+          <p:cNvSpPr txBox="1"/>
+          <p:nvPr/>
+        </p:nvSpPr>
+        <p:spPr>
+          <a:xfrm>
+            <a:off x="731520" y="1371600"/>
+            <a:ext cx="10607040" cy="4846320"/>
+          </a:xfrm>
+          <a:prstGeom prst="rect">
+            <a:avLst/>
+          </a:prstGeom>
+          <a:noFill/>
+        </p:spPr>
+        <p:txBody>
+          <a:bodyPr wrap="square">
+            <a:spAutoFit/>
+          </a:bodyPr>
+          <a:lstStyle/>
+          <a:p>
+            <a:pPr>
+              <a:spcAft>
+                <a:spcPts val="1000"/>
+              </a:spcAft>
+            </a:pPr>
+            <a:r>
+              <a:rPr sz="1600" b="1">
+                <a:solidFill>
+                  <a:srgbClr val="E8ECF8"/>
+                </a:solidFill>
+              </a:rPr>
+              <a:t>•  total_sqft is no longer dropped</a:t>
+            </a:r>
+          </a:p>
+          <a:p>
+            <a:pPr>
+              <a:spcAft>
+                <a:spcPts val="1000"/>
+              </a:spcAft>
+            </a:pPr>
+            <a:r>
+              <a:rPr sz="1600" b="0">
+                <a:solidFill>
+                  <a:srgbClr val="93A0C4"/>
+                </a:solidFill>
+              </a:rPr>
+              <a:t>•  Parses text values, converts sq.meter / yards / acre / perch to sqft, ranges become their midpoint</a:t>
+            </a:r>
+          </a:p>
+          <a:p>
+            <a:pPr>
+              <a:spcAft>
+                <a:spcPts val="1000"/>
+              </a:spcAft>
+            </a:pPr>
+            <a:r>
+              <a:rPr sz="1600" b="0">
+                <a:solidFill>
+                  <a:srgbClr val="93A0C4"/>
+                </a:solidFill>
+              </a:rPr>
+              <a:t>•  Removed 59 impossible rows (0.4%): 11 sqft flats, a 52,272 sqft house, 40-bathroom listings</a:t>
+            </a:r>
+          </a:p>
+          <a:p>
+            <a:pPr>
+              <a:spcAft>
+                <a:spcPts val="1000"/>
+              </a:spcAft>
+            </a:pPr>
+            <a:r>
+              <a:rPr sz="1600" b="1">
+                <a:solidFill>
+                  <a:srgbClr val="E8ECF8"/>
+                </a:solidFill>
+              </a:rPr>
+              <a:t>•  size -&gt; BHK count; availability -&gt; completion year (0 = ready to move)</a:t>
+            </a:r>
+          </a:p>
+          <a:p>
+            <a:pPr>
+              <a:spcAft>
+                <a:spcPts val="1000"/>
+              </a:spcAft>
+            </a:pPr>
+            <a:r>
+              <a:rPr sz="1600" b="0">
+                <a:solidFill>
+                  <a:srgbClr val="93A0C4"/>
+                </a:solidFill>
+              </a:rPr>
+              <a:t>•  location / society frequency encoded (1,124 locations, ~2,600 societies) — no fake order, no 5,600 sparse columns</a:t>
+            </a:r>
+          </a:p>
+          <a:p>
+            <a:pPr>
+              <a:spcAft>
+                <a:spcPts val="1000"/>
+              </a:spcAft>
+            </a:pPr>
+            <a:r>
+              <a:rPr sz="1600" b="1">
+                <a:solidFill>
+                  <a:srgbClr val="E8ECF8"/>
+                </a:solidFill>
+              </a:rPr>
+              <a:t>•  Log-price target tames the right tail; linear models trained on standardized features</a:t>
+            </a:r>
+          </a:p>
+          <a:p>
+            <a:pPr>
+              <a:spcAft>
+                <a:spcPts val="1000"/>
+              </a:spcAft>
+            </a:pPr>
+            <a:r>
+              <a:rPr sz="1600" b="0">
+                <a:solidFill>
+                  <a:srgbClr val="93A0C4"/>
+                </a:solidFill>
+              </a:rPr>
+              <a:t>•  Random Forest hyper-parameters chosen by 5-fold CV grid search (trees x leaf size)</a:t>
+            </a:r>
+          </a:p>
+        </p:txBody>
+      </p:sp>
+    </p:spTree>
+  </p:cSld>
+  <p:clrMapOvr>
+    <a:masterClrMapping/>
+  </p:clrMapOvr>
+</p:sld>
+</file>
+
 <file path=ppt/slides/slide26.xml><?xml version="1.0" encoding="utf-8"?>
 <p:sld xmlns:a="http://schemas.openxmlformats.org/drawingml/2006/main" xmlns:p="http://schemas.openxmlformats.org/presentationml/2006/main" xmlns:r="http://schemas.openxmlformats.org/officeDocument/2006/relationships">
   <p:cSld>
@@ -10369,7 +9671,7 @@
               </a:defRPr>
             </a:pPr>
             <a:r>
-              <a:t>v2 — Data Pipeline Improvements</a:t>
+              <a:t>v2 — Web App + REST API</a:t>
             </a:r>
           </a:p>
         </p:txBody>
@@ -10407,7 +9709,7 @@
                   <a:srgbClr val="E8ECF8"/>
                 </a:solidFill>
               </a:rPr>
-              <a:t>•  total_sqft is no longer dropped</a:t>
+              <a:t>•  Two faces, one set of models</a:t>
             </a:r>
           </a:p>
           <a:p>
@@ -10422,7 +9724,7 @@
                   <a:srgbClr val="93A0C4"/>
                 </a:solidFill>
               </a:rPr>
-              <a:t>•  Parses text values, converts sq.meter / yards / acre / perch to sqft, ranges become their midpoint</a:t>
+              <a:t>•  Streamlit app: model switcher, all 1,124 locations, Data &amp; EDA and Model Report pages</a:t>
             </a:r>
           </a:p>
           <a:p>
@@ -10437,7 +9739,7 @@
                   <a:srgbClr val="93A0C4"/>
                 </a:solidFill>
               </a:rPr>
-              <a:t>•  Removed 59 impossible rows (0.4%): 11 sqft flats, a 52,272 sqft house, 40-bathroom listings</a:t>
+              <a:t>•  FastAPI + custom single-page UI: one process, no build step, works offline</a:t>
             </a:r>
           </a:p>
           <a:p>
@@ -10452,7 +9754,7 @@
                   <a:srgbClr val="E8ECF8"/>
                 </a:solidFill>
               </a:rPr>
-              <a:t>•  size -&gt; BHK count; availability -&gt; completion year (0 = ready to move)</a:t>
+              <a:t>•  REST endpoints</a:t>
             </a:r>
           </a:p>
           <a:p>
@@ -10467,7 +9769,7 @@
                   <a:srgbClr val="93A0C4"/>
                 </a:solidFill>
               </a:rPr>
-              <a:t>•  location / society frequency encoded (1,124 locations, ~2,600 societies) — no fake order, no 5,600 sparse columns</a:t>
+              <a:t>•  POST /predict (any of the 3 models) · GET /models · /locations · /meta · /health · Swagger docs at /docs</a:t>
             </a:r>
           </a:p>
           <a:p>
@@ -10482,7 +9784,7 @@
                   <a:srgbClr val="E8ECF8"/>
                 </a:solidFill>
               </a:rPr>
-              <a:t>•  Log-price target tames the right tail; linear models trained on standardized features</a:t>
+              <a:t>•  Deployment &amp; quality</a:t>
             </a:r>
           </a:p>
           <a:p>
@@ -10497,7 +9799,7 @@
                   <a:srgbClr val="93A0C4"/>
                 </a:solidFill>
               </a:rPr>
-              <a:t>•  Random Forest hyper-parameters chosen by 5-fold CV grid search (trees x leaf size)</a:t>
+              <a:t>•  Docker image (one command) · pytest test suite · GitHub Actions CI on every push</a:t>
             </a:r>
           </a:p>
         </p:txBody>
@@ -10511,195 +9813,6 @@
 </file>
 
 <file path=ppt/slides/slide27.xml><?xml version="1.0" encoding="utf-8"?>
-<p:sld xmlns:a="http://schemas.openxmlformats.org/drawingml/2006/main" xmlns:p="http://schemas.openxmlformats.org/presentationml/2006/main" xmlns:r="http://schemas.openxmlformats.org/officeDocument/2006/relationships">
-  <p:cSld>
-    <p:bg>
-      <p:bgPr>
-        <a:solidFill>
-          <a:srgbClr val="0B1020"/>
-        </a:solidFill>
-        <a:effectLst/>
-      </p:bgPr>
-    </p:bg>
-    <p:spTree>
-      <p:nvGrpSpPr>
-        <p:cNvPr id="1" name=""/>
-        <p:cNvGrpSpPr/>
-        <p:nvPr/>
-      </p:nvGrpSpPr>
-      <p:grpSpPr/>
-      <p:sp>
-        <p:nvSpPr>
-          <p:cNvPr id="2" name="TextBox 1"/>
-          <p:cNvSpPr txBox="1"/>
-          <p:nvPr/>
-        </p:nvSpPr>
-        <p:spPr>
-          <a:xfrm>
-            <a:off x="548640" y="320040"/>
-            <a:ext cx="11064240" cy="822960"/>
-          </a:xfrm>
-          <a:prstGeom prst="rect">
-            <a:avLst/>
-          </a:prstGeom>
-          <a:noFill/>
-        </p:spPr>
-        <p:txBody>
-          <a:bodyPr wrap="none">
-            <a:spAutoFit/>
-          </a:bodyPr>
-          <a:lstStyle/>
-          <a:p>
-            <a:pPr>
-              <a:defRPr sz="3000" b="1">
-                <a:solidFill>
-                  <a:srgbClr val="E8ECF8"/>
-                </a:solidFill>
-              </a:defRPr>
-            </a:pPr>
-            <a:r>
-              <a:t>v2 — Web App + REST API</a:t>
-            </a:r>
-          </a:p>
-        </p:txBody>
-      </p:sp>
-      <p:sp>
-        <p:nvSpPr>
-          <p:cNvPr id="3" name="TextBox 2"/>
-          <p:cNvSpPr txBox="1"/>
-          <p:nvPr/>
-        </p:nvSpPr>
-        <p:spPr>
-          <a:xfrm>
-            <a:off x="731520" y="1371600"/>
-            <a:ext cx="10607040" cy="4846320"/>
-          </a:xfrm>
-          <a:prstGeom prst="rect">
-            <a:avLst/>
-          </a:prstGeom>
-          <a:noFill/>
-        </p:spPr>
-        <p:txBody>
-          <a:bodyPr wrap="square">
-            <a:spAutoFit/>
-          </a:bodyPr>
-          <a:lstStyle/>
-          <a:p>
-            <a:pPr>
-              <a:spcAft>
-                <a:spcPts val="1000"/>
-              </a:spcAft>
-            </a:pPr>
-            <a:r>
-              <a:rPr sz="1600" b="1">
-                <a:solidFill>
-                  <a:srgbClr val="E8ECF8"/>
-                </a:solidFill>
-              </a:rPr>
-              <a:t>•  Two faces, one set of models</a:t>
-            </a:r>
-          </a:p>
-          <a:p>
-            <a:pPr>
-              <a:spcAft>
-                <a:spcPts val="1000"/>
-              </a:spcAft>
-            </a:pPr>
-            <a:r>
-              <a:rPr sz="1600" b="0">
-                <a:solidFill>
-                  <a:srgbClr val="93A0C4"/>
-                </a:solidFill>
-              </a:rPr>
-              <a:t>•  Streamlit app: model switcher, all 1,124 locations, Data &amp; EDA and Model Report pages</a:t>
-            </a:r>
-          </a:p>
-          <a:p>
-            <a:pPr>
-              <a:spcAft>
-                <a:spcPts val="1000"/>
-              </a:spcAft>
-            </a:pPr>
-            <a:r>
-              <a:rPr sz="1600" b="0">
-                <a:solidFill>
-                  <a:srgbClr val="93A0C4"/>
-                </a:solidFill>
-              </a:rPr>
-              <a:t>•  FastAPI + custom single-page UI: one process, no build step, works offline</a:t>
-            </a:r>
-          </a:p>
-          <a:p>
-            <a:pPr>
-              <a:spcAft>
-                <a:spcPts val="1000"/>
-              </a:spcAft>
-            </a:pPr>
-            <a:r>
-              <a:rPr sz="1600" b="1">
-                <a:solidFill>
-                  <a:srgbClr val="E8ECF8"/>
-                </a:solidFill>
-              </a:rPr>
-              <a:t>•  REST endpoints</a:t>
-            </a:r>
-          </a:p>
-          <a:p>
-            <a:pPr>
-              <a:spcAft>
-                <a:spcPts val="1000"/>
-              </a:spcAft>
-            </a:pPr>
-            <a:r>
-              <a:rPr sz="1600" b="0">
-                <a:solidFill>
-                  <a:srgbClr val="93A0C4"/>
-                </a:solidFill>
-              </a:rPr>
-              <a:t>•  POST /predict (any of the 3 models) · GET /models · /locations · /meta · /health · Swagger docs at /docs</a:t>
-            </a:r>
-          </a:p>
-          <a:p>
-            <a:pPr>
-              <a:spcAft>
-                <a:spcPts val="1000"/>
-              </a:spcAft>
-            </a:pPr>
-            <a:r>
-              <a:rPr sz="1600" b="1">
-                <a:solidFill>
-                  <a:srgbClr val="E8ECF8"/>
-                </a:solidFill>
-              </a:rPr>
-              <a:t>•  Deployment &amp; quality</a:t>
-            </a:r>
-          </a:p>
-          <a:p>
-            <a:pPr>
-              <a:spcAft>
-                <a:spcPts val="1000"/>
-              </a:spcAft>
-            </a:pPr>
-            <a:r>
-              <a:rPr sz="1600" b="0">
-                <a:solidFill>
-                  <a:srgbClr val="93A0C4"/>
-                </a:solidFill>
-              </a:rPr>
-              <a:t>•  Docker image (one command) · pytest test suite · GitHub Actions CI on every push</a:t>
-            </a:r>
-          </a:p>
-        </p:txBody>
-      </p:sp>
-    </p:spTree>
-  </p:cSld>
-  <p:clrMapOvr>
-    <a:masterClrMapping/>
-  </p:clrMapOvr>
-</p:sld>
-</file>
-
-<file path=ppt/slides/slide28.xml><?xml version="1.0" encoding="utf-8"?>
 <p:sld xmlns:a="http://schemas.openxmlformats.org/drawingml/2006/main" xmlns:p="http://schemas.openxmlformats.org/presentationml/2006/main" xmlns:r="http://schemas.openxmlformats.org/officeDocument/2006/relationships">
   <p:cSld>
     <p:bg>
@@ -10841,6 +9954,175 @@
 </p:sld>
 </file>
 
+<file path=ppt/slides/slide28.xml><?xml version="1.0" encoding="utf-8"?>
+<p:sld xmlns:a="http://schemas.openxmlformats.org/drawingml/2006/main" xmlns:r="http://schemas.openxmlformats.org/officeDocument/2006/relationships" xmlns:p="http://schemas.openxmlformats.org/presentationml/2006/main">
+  <p:cSld>
+    <p:spTree>
+      <p:nvGrpSpPr>
+        <p:cNvPr id="1" name=""/>
+        <p:cNvGrpSpPr/>
+        <p:nvPr/>
+      </p:nvGrpSpPr>
+      <p:grpSpPr>
+        <a:xfrm>
+          <a:off x="0" y="0"/>
+          <a:ext cx="0" cy="0"/>
+          <a:chOff x="0" y="0"/>
+          <a:chExt cx="0" cy="0"/>
+        </a:xfrm>
+      </p:grpSpPr>
+      <p:sp>
+        <p:nvSpPr>
+          <p:cNvPr id="2" name="Title 1"/>
+          <p:cNvSpPr>
+            <a:spLocks noGrp="1"/>
+          </p:cNvSpPr>
+          <p:nvPr>
+            <p:ph type="title"/>
+          </p:nvPr>
+        </p:nvSpPr>
+        <p:spPr>
+          <a:xfrm>
+            <a:off x="974678" y="2480528"/>
+            <a:ext cx="10515600" cy="1325563"/>
+          </a:xfrm>
+        </p:spPr>
+        <p:txBody>
+          <a:bodyPr>
+            <a:normAutofit/>
+          </a:bodyPr>
+          <a:lstStyle/>
+          <a:p>
+            <a:pPr algn="ctr"/>
+            <a:r>
+              <a:rPr lang="en-US" sz="6000" b="1" i="1" dirty="0" smtClean="0">
+                <a:effectLst>
+                  <a:outerShdw blurRad="38100" dist="38100" dir="2700000" algn="tl">
+                    <a:srgbClr val="000000">
+                      <a:alpha val="43137"/>
+                    </a:srgbClr>
+                  </a:outerShdw>
+                </a:effectLst>
+                <a:latin typeface="Times New Roman" panose="02020603050405020304" pitchFamily="18" charset="0"/>
+                <a:cs typeface="Times New Roman" panose="02020603050405020304" pitchFamily="18" charset="0"/>
+              </a:rPr>
+              <a:t>Thank</a:t>
+            </a:r>
+            <a:r>
+              <a:rPr lang="en-US" sz="6000" b="1" dirty="0" smtClean="0">
+                <a:effectLst>
+                  <a:outerShdw blurRad="38100" dist="38100" dir="2700000" algn="tl">
+                    <a:srgbClr val="000000">
+                      <a:alpha val="43137"/>
+                    </a:srgbClr>
+                  </a:outerShdw>
+                </a:effectLst>
+                <a:latin typeface="Times New Roman" panose="02020603050405020304" pitchFamily="18" charset="0"/>
+                <a:cs typeface="Times New Roman" panose="02020603050405020304" pitchFamily="18" charset="0"/>
+              </a:rPr>
+              <a:t> </a:t>
+            </a:r>
+            <a:r>
+              <a:rPr lang="en-US" sz="6000" b="1" i="1" dirty="0">
+                <a:effectLst>
+                  <a:outerShdw blurRad="38100" dist="38100" dir="2700000" algn="tl">
+                    <a:srgbClr val="000000">
+                      <a:alpha val="43137"/>
+                    </a:srgbClr>
+                  </a:outerShdw>
+                </a:effectLst>
+                <a:latin typeface="Times New Roman" panose="02020603050405020304" pitchFamily="18" charset="0"/>
+                <a:cs typeface="Times New Roman" panose="02020603050405020304" pitchFamily="18" charset="0"/>
+              </a:rPr>
+              <a:t>Y</a:t>
+            </a:r>
+            <a:r>
+              <a:rPr lang="en-US" sz="6000" b="1" i="1" dirty="0" smtClean="0">
+                <a:effectLst>
+                  <a:outerShdw blurRad="38100" dist="38100" dir="2700000" algn="tl">
+                    <a:srgbClr val="000000">
+                      <a:alpha val="43137"/>
+                    </a:srgbClr>
+                  </a:outerShdw>
+                </a:effectLst>
+                <a:latin typeface="Times New Roman" panose="02020603050405020304" pitchFamily="18" charset="0"/>
+                <a:cs typeface="Times New Roman" panose="02020603050405020304" pitchFamily="18" charset="0"/>
+              </a:rPr>
+              <a:t>ou…</a:t>
+            </a:r>
+            <a:endParaRPr lang="en-IN" sz="6000" b="1" i="1" dirty="0">
+              <a:effectLst>
+                <a:outerShdw blurRad="38100" dist="38100" dir="2700000" algn="tl">
+                  <a:srgbClr val="000000">
+                    <a:alpha val="43137"/>
+                  </a:srgbClr>
+                </a:outerShdw>
+              </a:effectLst>
+              <a:latin typeface="Times New Roman" panose="02020603050405020304" pitchFamily="18" charset="0"/>
+              <a:cs typeface="Times New Roman" panose="02020603050405020304" pitchFamily="18" charset="0"/>
+            </a:endParaRPr>
+          </a:p>
+        </p:txBody>
+      </p:sp>
+      <p:sp>
+        <p:nvSpPr>
+          <p:cNvPr id="3" name="Rectangle 2"/>
+          <p:cNvSpPr/>
+          <p:nvPr/>
+        </p:nvSpPr>
+        <p:spPr>
+          <a:xfrm>
+            <a:off x="271463" y="242888"/>
+            <a:ext cx="11658600" cy="6386512"/>
+          </a:xfrm>
+          <a:prstGeom prst="rect">
+            <a:avLst/>
+          </a:prstGeom>
+          <a:noFill/>
+        </p:spPr>
+        <p:style>
+          <a:lnRef idx="2">
+            <a:schemeClr val="dk1"/>
+          </a:lnRef>
+          <a:fillRef idx="1">
+            <a:schemeClr val="lt1"/>
+          </a:fillRef>
+          <a:effectRef idx="0">
+            <a:schemeClr val="dk1"/>
+          </a:effectRef>
+          <a:fontRef idx="minor">
+            <a:schemeClr val="dk1"/>
+          </a:fontRef>
+        </p:style>
+        <p:txBody>
+          <a:bodyPr rtlCol="0" anchor="ctr"/>
+          <a:lstStyle/>
+          <a:p>
+            <a:pPr algn="ctr"/>
+            <a:endParaRPr lang="en-IN"/>
+          </a:p>
+        </p:txBody>
+      </p:sp>
+    </p:spTree>
+    <p:extLst>
+      <p:ext uri="{BB962C8B-B14F-4D97-AF65-F5344CB8AC3E}">
+        <p14:creationId xmlns:p14="http://schemas.microsoft.com/office/powerpoint/2010/main" val="511934383"/>
+      </p:ext>
+    </p:extLst>
+  </p:cSld>
+  <p:clrMapOvr>
+    <a:masterClrMapping/>
+  </p:clrMapOvr>
+  <p:timing>
+    <p:tnLst>
+      <p:par>
+        <p:cTn id="1" dur="indefinite" restart="never" nodeType="tmRoot"/>
+      </p:par>
+    </p:tnLst>
+  </p:timing>
+</p:sld>
+</file>
+
 <file path=ppt/slides/slide3.xml><?xml version="1.0" encoding="utf-8"?>
 <p:sld xmlns:a="http://schemas.openxmlformats.org/drawingml/2006/main" xmlns:r="http://schemas.openxmlformats.org/officeDocument/2006/relationships" xmlns:p="http://schemas.openxmlformats.org/presentationml/2006/main">
   <p:cSld>
@@ -10919,97 +10201,67 @@
               <a:buNone/>
             </a:pPr>
             <a:r>
-              <a:rPr lang="en-IN" sz="3200" dirty="0">
-                <a:latin typeface="Times New Roman" panose="02020603050405020304" pitchFamily="18" charset="0"/>
-                <a:cs typeface="Times New Roman" panose="02020603050405020304" pitchFamily="18" charset="0"/>
+              <a:rPr sz="3200">
+                <a:latin typeface="Times New Roman"/>
               </a:rPr>
-              <a:t>The main objective of our project is, </a:t>
-            </a:r>
-          </a:p>
-          <a:p>
-            <a:pPr>
+              <a:t>The main objective of this project is to predict house prices in Bengaluru from basic property details.</a:t>
+            </a:r>
+          </a:p>
+          <a:p>
+            <a:pPr marL="0" indent="0">
               <a:lnSpc>
                 <a:spcPct val="150000"/>
               </a:lnSpc>
+              <a:buNone/>
             </a:pPr>
             <a:r>
-              <a:rPr lang="en-IN" sz="3200" dirty="0" smtClean="0">
-                <a:latin typeface="Times New Roman" panose="02020603050405020304" pitchFamily="18" charset="0"/>
-                <a:cs typeface="Times New Roman" panose="02020603050405020304" pitchFamily="18" charset="0"/>
+              <a:rPr sz="3200">
+                <a:latin typeface="Times New Roman"/>
               </a:rPr>
-              <a:t>To </a:t>
-            </a:r>
-            <a:r>
-              <a:rPr lang="en-IN" sz="3200" dirty="0">
-                <a:latin typeface="Times New Roman" panose="02020603050405020304" pitchFamily="18" charset="0"/>
-                <a:cs typeface="Times New Roman" panose="02020603050405020304" pitchFamily="18" charset="0"/>
-              </a:rPr>
-              <a:t>predict the house price based on different locations.</a:t>
-            </a:r>
-          </a:p>
-          <a:p>
-            <a:pPr>
+              <a:t>To implement and compare three regression algorithms: Linear Regression, Ridge Regression and Random Forest.</a:t>
+            </a:r>
+          </a:p>
+          <a:p>
+            <a:pPr marL="0" indent="0">
               <a:lnSpc>
                 <a:spcPct val="150000"/>
               </a:lnSpc>
+              <a:buNone/>
             </a:pPr>
             <a:r>
-              <a:rPr lang="en-IN" sz="3200" dirty="0" smtClean="0">
-                <a:latin typeface="Times New Roman" panose="02020603050405020304" pitchFamily="18" charset="0"/>
-                <a:cs typeface="Times New Roman" panose="02020603050405020304" pitchFamily="18" charset="0"/>
+              <a:rPr sz="3200">
+                <a:latin typeface="Times New Roman"/>
               </a:rPr>
-              <a:t>To </a:t>
-            </a:r>
-            <a:r>
-              <a:rPr lang="en-IN" sz="3200" dirty="0">
-                <a:latin typeface="Times New Roman" panose="02020603050405020304" pitchFamily="18" charset="0"/>
-                <a:cs typeface="Times New Roman" panose="02020603050405020304" pitchFamily="18" charset="0"/>
-              </a:rPr>
-              <a:t>implement the machine learning </a:t>
-            </a:r>
-            <a:r>
-              <a:rPr lang="en-IN" sz="3200" dirty="0" smtClean="0">
-                <a:latin typeface="Times New Roman" panose="02020603050405020304" pitchFamily="18" charset="0"/>
-                <a:cs typeface="Times New Roman" panose="02020603050405020304" pitchFamily="18" charset="0"/>
-              </a:rPr>
-              <a:t>algorithm to find the mean error.</a:t>
-            </a:r>
-            <a:endParaRPr lang="en-IN" sz="3200" dirty="0">
-              <a:latin typeface="Times New Roman" panose="02020603050405020304" pitchFamily="18" charset="0"/>
-              <a:cs typeface="Times New Roman" panose="02020603050405020304" pitchFamily="18" charset="0"/>
-            </a:endParaRPr>
-          </a:p>
-          <a:p>
-            <a:pPr>
+              <a:t>To build a complete data pipeline: cleaning, unit conversion, feature engineering and encoding.</a:t>
+            </a:r>
+          </a:p>
+          <a:p>
+            <a:pPr marL="0" indent="0">
               <a:lnSpc>
                 <a:spcPct val="150000"/>
               </a:lnSpc>
+              <a:buNone/>
             </a:pPr>
             <a:r>
-              <a:rPr lang="en-IN" sz="3200" dirty="0" smtClean="0">
-                <a:latin typeface="Times New Roman" panose="02020603050405020304" pitchFamily="18" charset="0"/>
-                <a:cs typeface="Times New Roman" panose="02020603050405020304" pitchFamily="18" charset="0"/>
+              <a:rPr sz="3200">
+                <a:latin typeface="Times New Roman"/>
               </a:rPr>
-              <a:t>To </a:t>
-            </a:r>
-            <a:r>
-              <a:rPr lang="en-IN" sz="3200" dirty="0">
-                <a:latin typeface="Times New Roman" panose="02020603050405020304" pitchFamily="18" charset="0"/>
-                <a:cs typeface="Times New Roman" panose="02020603050405020304" pitchFamily="18" charset="0"/>
-              </a:rPr>
-              <a:t>enhance the overall performance for classification algorithms. </a:t>
-            </a:r>
-          </a:p>
-          <a:p>
-            <a:pPr>
+              <a:t>To evaluate the models with a 70/30 holdout split and 5-fold cross validation.</a:t>
+            </a:r>
+          </a:p>
+          <a:p>
+            <a:pPr marL="0" indent="0">
               <a:lnSpc>
                 <a:spcPct val="150000"/>
               </a:lnSpc>
+              <a:buNone/>
             </a:pPr>
-            <a:endParaRPr lang="en-IN" sz="3200" dirty="0">
-              <a:latin typeface="Times New Roman" panose="02020603050405020304" pitchFamily="18" charset="0"/>
-              <a:cs typeface="Times New Roman" panose="02020603050405020304" pitchFamily="18" charset="0"/>
-            </a:endParaRPr>
+            <a:r>
+              <a:rPr sz="3200">
+                <a:latin typeface="Times New Roman"/>
+              </a:rPr>
+              <a:t>To deliver predictions through a Streamlit app, a custom FastAPI web UI and a REST API.</a:t>
+            </a:r>
           </a:p>
         </p:txBody>
       </p:sp>
@@ -11198,92 +10450,10 @@
               </a:lnSpc>
             </a:pPr>
             <a:r>
-              <a:rPr lang="en-IN" sz="2000" dirty="0">
-                <a:latin typeface="Times New Roman" panose="02020603050405020304" pitchFamily="18" charset="0"/>
-                <a:cs typeface="Times New Roman" panose="02020603050405020304" pitchFamily="18" charset="0"/>
+              <a:rPr sz="2000">
+                <a:latin typeface="Times New Roman"/>
               </a:rPr>
-              <a:t>In existing, Predictive models for determining the sale price of houses in cities like Bengaluru is still remaining as more challenging and tricky task. The sale price of properties in cities like Bengaluru depends on a number of interdependent factors</a:t>
-            </a:r>
-            <a:r>
-              <a:rPr lang="en-IN" sz="2000" dirty="0" smtClean="0">
-                <a:latin typeface="Times New Roman" panose="02020603050405020304" pitchFamily="18" charset="0"/>
-                <a:cs typeface="Times New Roman" panose="02020603050405020304" pitchFamily="18" charset="0"/>
-              </a:rPr>
-              <a:t>.</a:t>
-            </a:r>
-          </a:p>
-          <a:p>
-            <a:pPr algn="just">
-              <a:lnSpc>
-                <a:spcPct val="150000"/>
-              </a:lnSpc>
-            </a:pPr>
-            <a:r>
-              <a:rPr lang="en-IN" sz="2000" dirty="0" smtClean="0">
-                <a:latin typeface="Times New Roman" panose="02020603050405020304" pitchFamily="18" charset="0"/>
-                <a:cs typeface="Times New Roman" panose="02020603050405020304" pitchFamily="18" charset="0"/>
-              </a:rPr>
-              <a:t> </a:t>
-            </a:r>
-            <a:r>
-              <a:rPr lang="en-IN" sz="2000" dirty="0">
-                <a:latin typeface="Times New Roman" panose="02020603050405020304" pitchFamily="18" charset="0"/>
-                <a:cs typeface="Times New Roman" panose="02020603050405020304" pitchFamily="18" charset="0"/>
-              </a:rPr>
-              <a:t>Key factors that might affect the price include area of the property, location of the property and its amenities. In this research work, an analytical study has been carried out by considering the data set that remains open to the public by illustrating the available housing properties in machine hackathon platform</a:t>
-            </a:r>
-            <a:r>
-              <a:rPr lang="en-IN" sz="2000" dirty="0" smtClean="0">
-                <a:latin typeface="Times New Roman" panose="02020603050405020304" pitchFamily="18" charset="0"/>
-                <a:cs typeface="Times New Roman" panose="02020603050405020304" pitchFamily="18" charset="0"/>
-              </a:rPr>
-              <a:t>.</a:t>
-            </a:r>
-          </a:p>
-          <a:p>
-            <a:pPr algn="just">
-              <a:lnSpc>
-                <a:spcPct val="150000"/>
-              </a:lnSpc>
-            </a:pPr>
-            <a:r>
-              <a:rPr lang="en-IN" sz="2000" dirty="0" smtClean="0">
-                <a:latin typeface="Times New Roman" panose="02020603050405020304" pitchFamily="18" charset="0"/>
-                <a:cs typeface="Times New Roman" panose="02020603050405020304" pitchFamily="18" charset="0"/>
-              </a:rPr>
-              <a:t> </a:t>
-            </a:r>
-            <a:r>
-              <a:rPr lang="en-IN" sz="2000" dirty="0">
-                <a:latin typeface="Times New Roman" panose="02020603050405020304" pitchFamily="18" charset="0"/>
-                <a:cs typeface="Times New Roman" panose="02020603050405020304" pitchFamily="18" charset="0"/>
-              </a:rPr>
-              <a:t>The data set has nine features. In this study, an attempt has been made to construct a predictive model for evaluating the price based on the factors that affect the price. </a:t>
-            </a:r>
-            <a:endParaRPr lang="en-IN" sz="2000" dirty="0" smtClean="0">
-              <a:latin typeface="Times New Roman" panose="02020603050405020304" pitchFamily="18" charset="0"/>
-              <a:cs typeface="Times New Roman" panose="02020603050405020304" pitchFamily="18" charset="0"/>
-            </a:endParaRPr>
-          </a:p>
-          <a:p>
-            <a:pPr algn="just">
-              <a:lnSpc>
-                <a:spcPct val="150000"/>
-              </a:lnSpc>
-            </a:pPr>
-            <a:r>
-              <a:rPr lang="en-IN" sz="2000" dirty="0" smtClean="0">
-                <a:latin typeface="Times New Roman" panose="02020603050405020304" pitchFamily="18" charset="0"/>
-                <a:cs typeface="Times New Roman" panose="02020603050405020304" pitchFamily="18" charset="0"/>
-              </a:rPr>
-              <a:t>Modelling </a:t>
-            </a:r>
-            <a:r>
-              <a:rPr lang="en-IN" sz="2000" dirty="0">
-                <a:latin typeface="Times New Roman" panose="02020603050405020304" pitchFamily="18" charset="0"/>
-                <a:cs typeface="Times New Roman" panose="02020603050405020304" pitchFamily="18" charset="0"/>
-              </a:rPr>
-              <a:t>explorations apply some regression techniques such as multiple linear regression (Least Squares), Lasso and Ridge regression models, support vector regression, and boosting algorithms such as Extreme Gradient Boost Regression (XG Boost). </a:t>
+              <a:t>In the existing process, price estimation relies on manual comparison of similar listings, broker intuition and spreadsheet heuristics. Data-driven predictive models for a city like Bengaluru are not readily available to an individual, and the process is slow, inconsistent and hard to scale across the 1,100+ localities of the city.</a:t>
             </a:r>
           </a:p>
         </p:txBody>
@@ -11424,11 +10594,10 @@
               </a:lnSpc>
             </a:pPr>
             <a:r>
-              <a:rPr lang="en-IN" sz="3200" dirty="0" smtClean="0">
-                <a:latin typeface="Times New Roman" panose="02020603050405020304" pitchFamily="18" charset="0"/>
-                <a:cs typeface="Times New Roman" panose="02020603050405020304" pitchFamily="18" charset="0"/>
+              <a:rPr sz="3200">
+                <a:latin typeface="Times New Roman"/>
               </a:rPr>
-              <a:t>The results is sometimes unproven when compared with proposed statement</a:t>
+              <a:t>Manual comparison is slow and depends entirely on the estimator's experience.</a:t>
             </a:r>
           </a:p>
           <a:p>
@@ -11438,11 +10607,10 @@
               </a:lnSpc>
             </a:pPr>
             <a:r>
-              <a:rPr lang="en-IN" sz="3200" dirty="0" smtClean="0">
-                <a:latin typeface="Times New Roman" panose="02020603050405020304" pitchFamily="18" charset="0"/>
-                <a:cs typeface="Times New Roman" panose="02020603050405020304" pitchFamily="18" charset="0"/>
+              <a:rPr sz="3200">
+                <a:latin typeface="Times New Roman"/>
               </a:rPr>
-              <a:t>It doesn’t efficient for large volume of data’s .</a:t>
+              <a:t>There is no consistent, data-driven method across Bengaluru's many localities.</a:t>
             </a:r>
           </a:p>
           <a:p>
@@ -11452,11 +10620,23 @@
               </a:lnSpc>
             </a:pPr>
             <a:r>
-              <a:rPr lang="en-IN" sz="3200" dirty="0" smtClean="0">
-                <a:latin typeface="Times New Roman" panose="02020603050405020304" pitchFamily="18" charset="0"/>
-                <a:cs typeface="Times New Roman" panose="02020603050405020304" pitchFamily="18" charset="0"/>
+              <a:rPr sz="3200">
+                <a:latin typeface="Times New Roman"/>
               </a:rPr>
-              <a:t>Theoretical limits due to inaccurate information.</a:t>
+              <a:t>Human estimates cannot capture the interactions between area, BHK and location.</a:t>
+            </a:r>
+          </a:p>
+          <a:p>
+            <a:pPr algn="just">
+              <a:lnSpc>
+                <a:spcPct val="150000"/>
+              </a:lnSpc>
+            </a:pPr>
+            <a:r>
+              <a:rPr sz="3200">
+                <a:latin typeface="Times New Roman"/>
+              </a:rPr>
+              <a:t>The results are not reproducible or auditable.</a:t>
             </a:r>
           </a:p>
         </p:txBody>
@@ -11597,158 +10777,10 @@
               </a:lnSpc>
             </a:pPr>
             <a:r>
-              <a:rPr lang="en-IN" sz="2000" dirty="0">
-                <a:latin typeface="Times New Roman" panose="02020603050405020304" pitchFamily="18" charset="0"/>
-                <a:cs typeface="Times New Roman" panose="02020603050405020304" pitchFamily="18" charset="0"/>
+              <a:rPr sz="2000">
+                <a:latin typeface="Times New Roman"/>
               </a:rPr>
-              <a:t>In this system, the house dataset was taken as input from the dataset </a:t>
-            </a:r>
-            <a:r>
-              <a:rPr lang="en-IN" sz="2000" dirty="0" smtClean="0">
-                <a:latin typeface="Times New Roman" panose="02020603050405020304" pitchFamily="18" charset="0"/>
-                <a:cs typeface="Times New Roman" panose="02020603050405020304" pitchFamily="18" charset="0"/>
-              </a:rPr>
-              <a:t>repository(KAGGLE,GITHUB). </a:t>
-            </a:r>
-            <a:r>
-              <a:rPr lang="en-IN" sz="2000" dirty="0">
-                <a:latin typeface="Times New Roman" panose="02020603050405020304" pitchFamily="18" charset="0"/>
-                <a:cs typeface="Times New Roman" panose="02020603050405020304" pitchFamily="18" charset="0"/>
-              </a:rPr>
-              <a:t>Then, we have to implement the data pre-processing step. In this step, we have to handle the missing values for avoid wrong prediction. Then, we have to split the data into test and train</a:t>
-            </a:r>
-            <a:r>
-              <a:rPr lang="en-IN" sz="2000" dirty="0" smtClean="0">
-                <a:latin typeface="Times New Roman" panose="02020603050405020304" pitchFamily="18" charset="0"/>
-                <a:cs typeface="Times New Roman" panose="02020603050405020304" pitchFamily="18" charset="0"/>
-              </a:rPr>
-              <a:t>.</a:t>
-            </a:r>
-          </a:p>
-          <a:p>
-            <a:pPr algn="just">
-              <a:lnSpc>
-                <a:spcPct val="150000"/>
-              </a:lnSpc>
-            </a:pPr>
-            <a:r>
-              <a:rPr lang="en-IN" sz="2000" dirty="0" smtClean="0">
-                <a:latin typeface="Times New Roman" panose="02020603050405020304" pitchFamily="18" charset="0"/>
-                <a:cs typeface="Times New Roman" panose="02020603050405020304" pitchFamily="18" charset="0"/>
-              </a:rPr>
-              <a:t> </a:t>
-            </a:r>
-            <a:r>
-              <a:rPr lang="en-IN" sz="2000" dirty="0">
-                <a:latin typeface="Times New Roman" panose="02020603050405020304" pitchFamily="18" charset="0"/>
-                <a:cs typeface="Times New Roman" panose="02020603050405020304" pitchFamily="18" charset="0"/>
-              </a:rPr>
-              <a:t>In this step, test is used for predict the model and train is used for evaluate the </a:t>
-            </a:r>
-            <a:r>
-              <a:rPr lang="en-IN" sz="2000" dirty="0" smtClean="0">
-                <a:latin typeface="Times New Roman" panose="02020603050405020304" pitchFamily="18" charset="0"/>
-                <a:cs typeface="Times New Roman" panose="02020603050405020304" pitchFamily="18" charset="0"/>
-              </a:rPr>
-              <a:t>model.</a:t>
-            </a:r>
-          </a:p>
-          <a:p>
-            <a:pPr algn="just">
-              <a:lnSpc>
-                <a:spcPct val="150000"/>
-              </a:lnSpc>
-            </a:pPr>
-            <a:r>
-              <a:rPr lang="en-IN" sz="2000" dirty="0" smtClean="0">
-                <a:latin typeface="Times New Roman" panose="02020603050405020304" pitchFamily="18" charset="0"/>
-                <a:cs typeface="Times New Roman" panose="02020603050405020304" pitchFamily="18" charset="0"/>
-              </a:rPr>
-              <a:t>We </a:t>
-            </a:r>
-            <a:r>
-              <a:rPr lang="en-IN" sz="2000" dirty="0">
-                <a:latin typeface="Times New Roman" panose="02020603050405020304" pitchFamily="18" charset="0"/>
-                <a:cs typeface="Times New Roman" panose="02020603050405020304" pitchFamily="18" charset="0"/>
-              </a:rPr>
-              <a:t>have to implement the machine learning regression algorithms such as Ridge and </a:t>
-            </a:r>
-            <a:r>
-              <a:rPr lang="en-IN" dirty="0">
-                <a:latin typeface="Times New Roman" panose="02020603050405020304" pitchFamily="18" charset="0"/>
-                <a:cs typeface="Times New Roman" panose="02020603050405020304" pitchFamily="18" charset="0"/>
-              </a:rPr>
-              <a:t>R</a:t>
-            </a:r>
-            <a:r>
-              <a:rPr lang="en-IN" sz="2000" dirty="0" smtClean="0">
-                <a:latin typeface="Times New Roman" panose="02020603050405020304" pitchFamily="18" charset="0"/>
-                <a:cs typeface="Times New Roman" panose="02020603050405020304" pitchFamily="18" charset="0"/>
-              </a:rPr>
-              <a:t>andom </a:t>
-            </a:r>
-            <a:r>
-              <a:rPr lang="en-IN" dirty="0">
-                <a:latin typeface="Times New Roman" panose="02020603050405020304" pitchFamily="18" charset="0"/>
-                <a:cs typeface="Times New Roman" panose="02020603050405020304" pitchFamily="18" charset="0"/>
-              </a:rPr>
-              <a:t>F</a:t>
-            </a:r>
-            <a:r>
-              <a:rPr lang="en-IN" sz="2000" dirty="0" smtClean="0">
-                <a:latin typeface="Times New Roman" panose="02020603050405020304" pitchFamily="18" charset="0"/>
-                <a:cs typeface="Times New Roman" panose="02020603050405020304" pitchFamily="18" charset="0"/>
-              </a:rPr>
-              <a:t>orest </a:t>
-            </a:r>
-            <a:r>
-              <a:rPr lang="en-IN" dirty="0" smtClean="0">
-                <a:latin typeface="Times New Roman" panose="02020603050405020304" pitchFamily="18" charset="0"/>
-                <a:cs typeface="Times New Roman" panose="02020603050405020304" pitchFamily="18" charset="0"/>
-              </a:rPr>
-              <a:t>R</a:t>
-            </a:r>
-            <a:r>
-              <a:rPr lang="en-IN" sz="2000" dirty="0" smtClean="0">
-                <a:latin typeface="Times New Roman" panose="02020603050405020304" pitchFamily="18" charset="0"/>
-                <a:cs typeface="Times New Roman" panose="02020603050405020304" pitchFamily="18" charset="0"/>
-              </a:rPr>
-              <a:t>egression .</a:t>
-            </a:r>
-          </a:p>
-          <a:p>
-            <a:pPr algn="just">
-              <a:lnSpc>
-                <a:spcPct val="150000"/>
-              </a:lnSpc>
-            </a:pPr>
-            <a:r>
-              <a:rPr lang="en-IN" sz="2000" dirty="0" smtClean="0">
-                <a:latin typeface="Times New Roman" panose="02020603050405020304" pitchFamily="18" charset="0"/>
-                <a:cs typeface="Times New Roman" panose="02020603050405020304" pitchFamily="18" charset="0"/>
-              </a:rPr>
-              <a:t>Finally</a:t>
-            </a:r>
-            <a:r>
-              <a:rPr lang="en-IN" sz="2000" dirty="0">
-                <a:latin typeface="Times New Roman" panose="02020603050405020304" pitchFamily="18" charset="0"/>
-                <a:cs typeface="Times New Roman" panose="02020603050405020304" pitchFamily="18" charset="0"/>
-              </a:rPr>
-              <a:t>, the experimental results shows that the performance metrics such as </a:t>
-            </a:r>
-            <a:r>
-              <a:rPr lang="en-IN" sz="2000" dirty="0" smtClean="0">
-                <a:latin typeface="Times New Roman" panose="02020603050405020304" pitchFamily="18" charset="0"/>
-                <a:cs typeface="Times New Roman" panose="02020603050405020304" pitchFamily="18" charset="0"/>
-              </a:rPr>
-              <a:t>MAE(Mean Absolute Error) instead of Accuracy and </a:t>
-            </a:r>
-            <a:r>
-              <a:rPr lang="en-IN" sz="2000" dirty="0">
-                <a:latin typeface="Times New Roman" panose="02020603050405020304" pitchFamily="18" charset="0"/>
-                <a:cs typeface="Times New Roman" panose="02020603050405020304" pitchFamily="18" charset="0"/>
-              </a:rPr>
-              <a:t>predict the house price based on input attributes.</a:t>
+              <a:t>In this system, the Bengaluru housing dataset is taken from Kaggle. The data is cleaned - area values in sq.meter / yards / acre / perch are converted to sqft and rows with physically impossible measurements are removed - and features are engineered (BHK count, completion year, frequency-encoded location and society). Three regression models (Linear, Ridge and a tuned Random Forest) are trained on a log-price target and compared on a held-out test set. The trained models are deployed through a Streamlit app, a custom FastAPI web UI and a REST API, packaged in Docker.</a:t>
             </a:r>
           </a:p>
         </p:txBody>
@@ -11889,32 +10921,10 @@
               </a:lnSpc>
             </a:pPr>
             <a:r>
-              <a:rPr lang="en-IN" sz="3200" dirty="0" smtClean="0">
-                <a:latin typeface="Times New Roman" panose="02020603050405020304" pitchFamily="18" charset="0"/>
-                <a:cs typeface="Times New Roman" panose="02020603050405020304" pitchFamily="18" charset="0"/>
+              <a:rPr sz="3200">
+                <a:latin typeface="Times New Roman"/>
               </a:rPr>
-              <a:t>It </a:t>
-            </a:r>
-            <a:r>
-              <a:rPr lang="en-IN" sz="3200" dirty="0">
-                <a:latin typeface="Times New Roman" panose="02020603050405020304" pitchFamily="18" charset="0"/>
-                <a:cs typeface="Times New Roman" panose="02020603050405020304" pitchFamily="18" charset="0"/>
-              </a:rPr>
-              <a:t>is </a:t>
-            </a:r>
-            <a:r>
-              <a:rPr lang="en-IN" sz="3200" dirty="0" smtClean="0">
-                <a:latin typeface="Times New Roman" panose="02020603050405020304" pitchFamily="18" charset="0"/>
-                <a:cs typeface="Times New Roman" panose="02020603050405020304" pitchFamily="18" charset="0"/>
-              </a:rPr>
-              <a:t>the efficient method for </a:t>
-            </a:r>
-            <a:r>
-              <a:rPr lang="en-IN" sz="3200" dirty="0">
-                <a:latin typeface="Times New Roman" panose="02020603050405020304" pitchFamily="18" charset="0"/>
-                <a:cs typeface="Times New Roman" panose="02020603050405020304" pitchFamily="18" charset="0"/>
-              </a:rPr>
-              <a:t>large number of datasets.</a:t>
+              <a:t>Efficient on the full dataset of 13,320 listings across ~1,100 localities.</a:t>
             </a:r>
           </a:p>
           <a:p>
@@ -11924,16 +10934,11 @@
               </a:lnSpc>
             </a:pPr>
             <a:r>
-              <a:rPr lang="en-IN" sz="3200" dirty="0" smtClean="0">
-                <a:latin typeface="Times New Roman" panose="02020603050405020304" pitchFamily="18" charset="0"/>
-                <a:cs typeface="Times New Roman" panose="02020603050405020304" pitchFamily="18" charset="0"/>
+              <a:rPr sz="3200">
+                <a:latin typeface="Times New Roman"/>
               </a:rPr>
-              <a:t>The process is implemented with removing the unwanted data.</a:t>
-            </a:r>
-            <a:endParaRPr lang="en-IN" sz="3200" dirty="0">
-              <a:latin typeface="Times New Roman" panose="02020603050405020304" pitchFamily="18" charset="0"/>
-              <a:cs typeface="Times New Roman" panose="02020603050405020304" pitchFamily="18" charset="0"/>
-            </a:endParaRPr>
+              <a:t>Unwanted data is removed and all area units are normalized before training.</a:t>
+            </a:r>
           </a:p>
           <a:p>
             <a:pPr algn="just">
@@ -11942,30 +10947,11 @@
               </a:lnSpc>
             </a:pPr>
             <a:r>
-              <a:rPr lang="en-IN" sz="3200" dirty="0" smtClean="0">
-                <a:latin typeface="Times New Roman" panose="02020603050405020304" pitchFamily="18" charset="0"/>
-                <a:cs typeface="Times New Roman" panose="02020603050405020304" pitchFamily="18" charset="0"/>
+              <a:rPr sz="3200">
+                <a:latin typeface="Times New Roman"/>
               </a:rPr>
-              <a:t>The </a:t>
-            </a:r>
-            <a:r>
-              <a:rPr lang="en-IN" sz="3200" dirty="0">
-                <a:latin typeface="Times New Roman" panose="02020603050405020304" pitchFamily="18" charset="0"/>
-                <a:cs typeface="Times New Roman" panose="02020603050405020304" pitchFamily="18" charset="0"/>
-              </a:rPr>
-              <a:t>prediction is </a:t>
-            </a:r>
-            <a:r>
-              <a:rPr lang="en-IN" sz="3200" dirty="0" smtClean="0">
-                <a:latin typeface="Times New Roman" panose="02020603050405020304" pitchFamily="18" charset="0"/>
-                <a:cs typeface="Times New Roman" panose="02020603050405020304" pitchFamily="18" charset="0"/>
-              </a:rPr>
-              <a:t>efficient by using regression techniques.</a:t>
-            </a:r>
-            <a:endParaRPr lang="en-IN" sz="3200" dirty="0">
-              <a:latin typeface="Times New Roman" panose="02020603050405020304" pitchFamily="18" charset="0"/>
-              <a:cs typeface="Times New Roman" panose="02020603050405020304" pitchFamily="18" charset="0"/>
-            </a:endParaRPr>
+              <a:t>Three models are compared with cross validation; the best model is chosen by evidence.</a:t>
+            </a:r>
           </a:p>
           <a:p>
             <a:pPr algn="just">
@@ -11973,10 +10959,25 @@
                 <a:spcPct val="150000"/>
               </a:lnSpc>
             </a:pPr>
-            <a:endParaRPr lang="en-IN" sz="2000" dirty="0">
-              <a:latin typeface="Times New Roman" panose="02020603050405020304" pitchFamily="18" charset="0"/>
-              <a:cs typeface="Times New Roman" panose="02020603050405020304" pitchFamily="18" charset="0"/>
-            </a:endParaRPr>
+            <a:r>
+              <a:rPr sz="3200">
+                <a:latin typeface="Times New Roman"/>
+              </a:rPr>
+              <a:t>Non-linear interactions (area x BHK x location) are captured by the Random Forest.</a:t>
+            </a:r>
+          </a:p>
+          <a:p>
+            <a:pPr algn="just">
+              <a:lnSpc>
+                <a:spcPct val="150000"/>
+              </a:lnSpc>
+            </a:pPr>
+            <a:r>
+              <a:rPr sz="3200">
+                <a:latin typeface="Times New Roman"/>
+              </a:rPr>
+              <a:t>Instant prediction through a web app and a REST API; one-command Docker deployment.</a:t>
+            </a:r>
           </a:p>
         </p:txBody>
       </p:sp>
@@ -12186,15 +11187,10 @@
                 </a:spcAft>
               </a:pPr>
               <a:r>
-                <a:rPr lang="en-US" sz="1200" kern="1200">
-                  <a:solidFill>
-                    <a:srgbClr val="000000"/>
-                  </a:solidFill>
-                  <a:effectLst/>
-                  <a:latin typeface="Times New Roman" panose="02020603050405020304" pitchFamily="18" charset="0"/>
-                  <a:ea typeface="Times New Roman" panose="02020603050405020304" pitchFamily="18" charset="0"/>
+                <a:rPr sz="1200">
+                  <a:latin typeface="Times New Roman"/>
                 </a:rPr>
-                <a:t>Input data</a:t>
+                <a:t>Data loading</a:t>
               </a:r>
               <a:endParaRPr lang="en-IN" sz="1200">
                 <a:effectLst/>
@@ -12244,15 +11240,10 @@
                 </a:spcAft>
               </a:pPr>
               <a:r>
-                <a:rPr lang="en-US" sz="1200" kern="1200">
-                  <a:solidFill>
-                    <a:srgbClr val="000000"/>
-                  </a:solidFill>
-                  <a:effectLst/>
-                  <a:latin typeface="Times New Roman" panose="02020603050405020304" pitchFamily="18" charset="0"/>
-                  <a:ea typeface="Times New Roman" panose="02020603050405020304" pitchFamily="18" charset="0"/>
+                <a:rPr sz="1200">
+                  <a:latin typeface="Times New Roman"/>
                 </a:rPr>
-                <a:t>Preprocessing </a:t>
+                <a:t>Preprocessing &amp; features</a:t>
               </a:r>
               <a:endParaRPr lang="en-IN" sz="1200">
                 <a:effectLst/>
@@ -12302,15 +11293,10 @@
                 </a:spcAft>
               </a:pPr>
               <a:r>
-                <a:rPr lang="en-US" sz="1200" kern="1200">
-                  <a:solidFill>
-                    <a:srgbClr val="000000"/>
-                  </a:solidFill>
-                  <a:effectLst/>
-                  <a:latin typeface="Times New Roman" panose="02020603050405020304" pitchFamily="18" charset="0"/>
-                  <a:ea typeface="Times New Roman" panose="02020603050405020304" pitchFamily="18" charset="0"/>
+                <a:rPr sz="1200">
+                  <a:latin typeface="Times New Roman"/>
                 </a:rPr>
-                <a:t>Data Splitting</a:t>
+                <a:t>Data splitting 70/30</a:t>
               </a:r>
               <a:endParaRPr lang="en-IN" sz="1200">
                 <a:effectLst/>
@@ -12360,15 +11346,10 @@
                 </a:spcAft>
               </a:pPr>
               <a:r>
-                <a:rPr lang="en-US" sz="1200" kern="1200">
-                  <a:solidFill>
-                    <a:srgbClr val="000000"/>
-                  </a:solidFill>
-                  <a:effectLst/>
-                  <a:latin typeface="Times New Roman" panose="02020603050405020304" pitchFamily="18" charset="0"/>
-                  <a:ea typeface="Times New Roman" panose="02020603050405020304" pitchFamily="18" charset="0"/>
+                <a:rPr sz="1200">
+                  <a:latin typeface="Times New Roman"/>
                 </a:rPr>
-                <a:t>Classification</a:t>
+                <a:t>Model training</a:t>
               </a:r>
               <a:endParaRPr lang="en-IN" sz="1200">
                 <a:effectLst/>
@@ -12418,15 +11399,10 @@
                 </a:spcAft>
               </a:pPr>
               <a:r>
-                <a:rPr lang="en-US" sz="1200" kern="1200">
-                  <a:solidFill>
-                    <a:srgbClr val="000000"/>
-                  </a:solidFill>
-                  <a:effectLst/>
-                  <a:latin typeface="Times New Roman" panose="02020603050405020304" pitchFamily="18" charset="0"/>
-                  <a:ea typeface="Times New Roman" panose="02020603050405020304" pitchFamily="18" charset="0"/>
+                <a:rPr sz="1200">
+                  <a:latin typeface="Times New Roman"/>
                 </a:rPr>
-                <a:t>Performance Analysis</a:t>
+                <a:t>Evaluation (R2, MAE)</a:t>
               </a:r>
               <a:endParaRPr lang="en-IN" sz="1200">
                 <a:effectLst/>
@@ -12476,15 +11452,10 @@
                 </a:spcAft>
               </a:pPr>
               <a:r>
-                <a:rPr lang="en-US" sz="1200" kern="1200" dirty="0">
-                  <a:solidFill>
-                    <a:srgbClr val="000000"/>
-                  </a:solidFill>
-                  <a:effectLst/>
-                  <a:latin typeface="Times New Roman" panose="02020603050405020304" pitchFamily="18" charset="0"/>
-                  <a:ea typeface="Times New Roman" panose="02020603050405020304" pitchFamily="18" charset="0"/>
+                <a:rPr sz="1200">
+                  <a:latin typeface="Times New Roman"/>
                 </a:rPr>
-                <a:t>Data set ( House dataset)</a:t>
+                <a:t>Bengaluru housing dataset (Kaggle)</a:t>
               </a:r>
               <a:endParaRPr lang="en-IN" sz="1200" dirty="0">
                 <a:effectLst/>
@@ -12572,15 +11543,10 @@
                 </a:spcAft>
               </a:pPr>
               <a:r>
-                <a:rPr lang="en-US" sz="1200" kern="1200">
-                  <a:solidFill>
-                    <a:srgbClr val="000000"/>
-                  </a:solidFill>
-                  <a:effectLst/>
-                  <a:latin typeface="Times New Roman" panose="02020603050405020304" pitchFamily="18" charset="0"/>
-                  <a:ea typeface="Times New Roman" panose="02020603050405020304" pitchFamily="18" charset="0"/>
+                <a:rPr sz="1200">
+                  <a:latin typeface="Times New Roman"/>
                 </a:rPr>
-                <a:t>Handle missing value </a:t>
+                <a:t>Unit conversion + row cleaning</a:t>
               </a:r>
               <a:endParaRPr lang="en-IN" sz="1200">
                 <a:effectLst/>
@@ -12920,15 +11886,10 @@
                 </a:spcAft>
               </a:pPr>
               <a:r>
-                <a:rPr lang="en-US" sz="1200" kern="1200">
-                  <a:solidFill>
-                    <a:srgbClr val="000000"/>
-                  </a:solidFill>
-                  <a:effectLst/>
-                  <a:latin typeface="Times New Roman" panose="02020603050405020304" pitchFamily="18" charset="0"/>
-                  <a:ea typeface="Times New Roman" panose="02020603050405020304" pitchFamily="18" charset="0"/>
+                <a:rPr sz="1200">
+                  <a:latin typeface="Times New Roman"/>
                 </a:rPr>
-                <a:t>Random Forest Regressor</a:t>
+                <a:t>Linear + Ridge + Random Forest</a:t>
               </a:r>
               <a:endParaRPr lang="en-IN" sz="1200">
                 <a:effectLst/>
@@ -12978,15 +11939,10 @@
                 </a:spcAft>
               </a:pPr>
               <a:r>
-                <a:rPr lang="en-US" sz="1200" kern="1200">
-                  <a:solidFill>
-                    <a:srgbClr val="000000"/>
-                  </a:solidFill>
-                  <a:effectLst/>
-                  <a:latin typeface="Times New Roman" panose="02020603050405020304" pitchFamily="18" charset="0"/>
-                  <a:ea typeface="Times New Roman" panose="02020603050405020304" pitchFamily="18" charset="0"/>
+                <a:rPr sz="1200">
+                  <a:latin typeface="Times New Roman"/>
                 </a:rPr>
-                <a:t>Ridge Regressor</a:t>
+                <a:t>5-fold CV + tuning</a:t>
               </a:r>
               <a:endParaRPr lang="en-IN" sz="1200">
                 <a:effectLst/>
@@ -13036,15 +11992,10 @@
                 </a:spcAft>
               </a:pPr>
               <a:r>
-                <a:rPr lang="en-US" sz="1200" kern="1200">
-                  <a:solidFill>
-                    <a:srgbClr val="000000"/>
-                  </a:solidFill>
-                  <a:effectLst/>
-                  <a:latin typeface="Times New Roman" panose="02020603050405020304" pitchFamily="18" charset="0"/>
-                  <a:ea typeface="Times New Roman" panose="02020603050405020304" pitchFamily="18" charset="0"/>
+                <a:rPr sz="1200">
+                  <a:latin typeface="Times New Roman"/>
                 </a:rPr>
-                <a:t>Label Encoding</a:t>
+                <a:t>BHK / year derivation</a:t>
               </a:r>
               <a:endParaRPr lang="en-IN" sz="1200">
                 <a:effectLst/>
@@ -13132,15 +12083,10 @@
                 </a:spcAft>
               </a:pPr>
               <a:r>
-                <a:rPr lang="en-US" sz="1200" kern="1200">
-                  <a:solidFill>
-                    <a:srgbClr val="000000"/>
-                  </a:solidFill>
-                  <a:effectLst/>
-                  <a:latin typeface="Times New Roman" panose="02020603050405020304" pitchFamily="18" charset="0"/>
-                  <a:ea typeface="Times New Roman" panose="02020603050405020304" pitchFamily="18" charset="0"/>
+                <a:rPr sz="1200">
+                  <a:latin typeface="Times New Roman"/>
                 </a:rPr>
-                <a:t>Test</a:t>
+                <a:t>Test (3,979 rows)</a:t>
               </a:r>
               <a:endParaRPr lang="en-IN" sz="1200">
                 <a:effectLst/>
@@ -13190,15 +12136,10 @@
                 </a:spcAft>
               </a:pPr>
               <a:r>
-                <a:rPr lang="en-US" sz="1200" kern="1200">
-                  <a:solidFill>
-                    <a:srgbClr val="000000"/>
-                  </a:solidFill>
-                  <a:effectLst/>
-                  <a:latin typeface="Times New Roman" panose="02020603050405020304" pitchFamily="18" charset="0"/>
-                  <a:ea typeface="Times New Roman" panose="02020603050405020304" pitchFamily="18" charset="0"/>
+                <a:rPr sz="1200">
+                  <a:latin typeface="Times New Roman"/>
                 </a:rPr>
-                <a:t>Drop unwanted columns</a:t>
+                <a:t>Frequency encoding</a:t>
               </a:r>
               <a:endParaRPr lang="en-IN" sz="1200">
                 <a:effectLst/>
@@ -13248,15 +12189,10 @@
                 </a:spcAft>
               </a:pPr>
               <a:r>
-                <a:rPr lang="en-US" sz="1200" kern="1200">
-                  <a:solidFill>
-                    <a:srgbClr val="000000"/>
-                  </a:solidFill>
-                  <a:effectLst/>
-                  <a:latin typeface="Times New Roman" panose="02020603050405020304" pitchFamily="18" charset="0"/>
-                  <a:ea typeface="Times New Roman" panose="02020603050405020304" pitchFamily="18" charset="0"/>
+                <a:rPr sz="1200">
+                  <a:latin typeface="Times New Roman"/>
                 </a:rPr>
-                <a:t>Train </a:t>
+                <a:t>Train (9,282 rows)</a:t>
               </a:r>
               <a:endParaRPr lang="en-IN" sz="1200">
                 <a:effectLst/>
@@ -13418,15 +12354,10 @@
                 </a:spcAft>
               </a:pPr>
               <a:r>
-                <a:rPr lang="en-US" sz="1200" kern="1200">
-                  <a:solidFill>
-                    <a:srgbClr val="000000"/>
-                  </a:solidFill>
-                  <a:effectLst/>
-                  <a:latin typeface="Times New Roman" panose="02020603050405020304" pitchFamily="18" charset="0"/>
-                  <a:ea typeface="Times New Roman" panose="02020603050405020304" pitchFamily="18" charset="0"/>
+                <a:rPr sz="1200">
+                  <a:latin typeface="Times New Roman"/>
                 </a:rPr>
-                <a:t>MAE</a:t>
+                <a:t>Save models</a:t>
               </a:r>
               <a:endParaRPr lang="en-IN" sz="1200">
                 <a:effectLst/>
@@ -13476,15 +12407,10 @@
                 </a:spcAft>
               </a:pPr>
               <a:r>
-                <a:rPr lang="en-US" sz="1200" kern="1200">
-                  <a:solidFill>
-                    <a:srgbClr val="000000"/>
-                  </a:solidFill>
-                  <a:effectLst/>
-                  <a:latin typeface="Times New Roman" panose="02020603050405020304" pitchFamily="18" charset="0"/>
-                  <a:ea typeface="Times New Roman" panose="02020603050405020304" pitchFamily="18" charset="0"/>
+                <a:rPr sz="1200">
+                  <a:latin typeface="Times New Roman"/>
                 </a:rPr>
-                <a:t>Predict the house price</a:t>
+                <a:t>Web app + REST API</a:t>
               </a:r>
               <a:endParaRPr lang="en-IN" sz="1200">
                 <a:effectLst/>
@@ -13623,18 +12549,10 @@
               </a:lnSpc>
             </a:pPr>
             <a:r>
-              <a:rPr lang="en-US" sz="2000" dirty="0" smtClean="0">
-                <a:latin typeface="Times New Roman" panose="02020603050405020304" pitchFamily="18" charset="0"/>
-                <a:cs typeface="Times New Roman" panose="02020603050405020304" pitchFamily="18" charset="0"/>
+              <a:rPr sz="2000">
+                <a:latin typeface="Times New Roman"/>
               </a:rPr>
-              <a:t>Data </a:t>
-            </a:r>
-            <a:r>
-              <a:rPr lang="en-US" sz="2000" dirty="0">
-                <a:latin typeface="Times New Roman" panose="02020603050405020304" pitchFamily="18" charset="0"/>
-                <a:cs typeface="Times New Roman" panose="02020603050405020304" pitchFamily="18" charset="0"/>
-              </a:rPr>
-              <a:t>selection</a:t>
+              <a:t>Data selection</a:t>
             </a:r>
           </a:p>
           <a:p>
@@ -13644,18 +12562,10 @@
               </a:lnSpc>
             </a:pPr>
             <a:r>
-              <a:rPr lang="en-US" sz="2000" dirty="0" smtClean="0">
-                <a:latin typeface="Times New Roman" panose="02020603050405020304" pitchFamily="18" charset="0"/>
-                <a:cs typeface="Times New Roman" panose="02020603050405020304" pitchFamily="18" charset="0"/>
+              <a:rPr sz="2000">
+                <a:latin typeface="Times New Roman"/>
               </a:rPr>
-              <a:t>Data </a:t>
-            </a:r>
-            <a:r>
-              <a:rPr lang="en-US" sz="2000" dirty="0">
-                <a:latin typeface="Times New Roman" panose="02020603050405020304" pitchFamily="18" charset="0"/>
-                <a:cs typeface="Times New Roman" panose="02020603050405020304" pitchFamily="18" charset="0"/>
-              </a:rPr>
-              <a:t>preprocessing</a:t>
+              <a:t>Data preprocessing and feature engineering</a:t>
             </a:r>
           </a:p>
           <a:p>
@@ -13665,18 +12575,10 @@
               </a:lnSpc>
             </a:pPr>
             <a:r>
-              <a:rPr lang="en-US" sz="2000" dirty="0" smtClean="0">
-                <a:latin typeface="Times New Roman" panose="02020603050405020304" pitchFamily="18" charset="0"/>
-                <a:cs typeface="Times New Roman" panose="02020603050405020304" pitchFamily="18" charset="0"/>
+              <a:rPr sz="2000">
+                <a:latin typeface="Times New Roman"/>
               </a:rPr>
-              <a:t>Data </a:t>
-            </a:r>
-            <a:r>
-              <a:rPr lang="en-US" sz="2000" dirty="0">
-                <a:latin typeface="Times New Roman" panose="02020603050405020304" pitchFamily="18" charset="0"/>
-                <a:cs typeface="Times New Roman" panose="02020603050405020304" pitchFamily="18" charset="0"/>
-              </a:rPr>
-              <a:t>splitting </a:t>
+              <a:t>Data splitting</a:t>
             </a:r>
           </a:p>
           <a:p>
@@ -13686,16 +12588,11 @@
               </a:lnSpc>
             </a:pPr>
             <a:r>
-              <a:rPr lang="en-US" sz="2000" dirty="0" smtClean="0">
-                <a:latin typeface="Times New Roman" panose="02020603050405020304" pitchFamily="18" charset="0"/>
-                <a:cs typeface="Times New Roman" panose="02020603050405020304" pitchFamily="18" charset="0"/>
+              <a:rPr sz="2000">
+                <a:latin typeface="Times New Roman"/>
               </a:rPr>
-              <a:t>Classification</a:t>
-            </a:r>
-            <a:endParaRPr lang="en-US" sz="2000" dirty="0">
-              <a:latin typeface="Times New Roman" panose="02020603050405020304" pitchFamily="18" charset="0"/>
-              <a:cs typeface="Times New Roman" panose="02020603050405020304" pitchFamily="18" charset="0"/>
-            </a:endParaRPr>
+              <a:t>Model training (Linear / Ridge / Random Forest)</a:t>
+            </a:r>
           </a:p>
           <a:p>
             <a:pPr lvl="0" algn="just">
@@ -13704,18 +12601,23 @@
               </a:lnSpc>
             </a:pPr>
             <a:r>
-              <a:rPr lang="en-US" sz="2000" dirty="0" smtClean="0">
-                <a:latin typeface="Times New Roman" panose="02020603050405020304" pitchFamily="18" charset="0"/>
-                <a:cs typeface="Times New Roman" panose="02020603050405020304" pitchFamily="18" charset="0"/>
+              <a:rPr sz="2000">
+                <a:latin typeface="Times New Roman"/>
               </a:rPr>
-              <a:t>Result </a:t>
-            </a:r>
-            <a:r>
-              <a:rPr lang="en-US" sz="2000" dirty="0">
-                <a:latin typeface="Times New Roman" panose="02020603050405020304" pitchFamily="18" charset="0"/>
-                <a:cs typeface="Times New Roman" panose="02020603050405020304" pitchFamily="18" charset="0"/>
+              <a:t>Evaluation and diagnostics</a:t>
+            </a:r>
+          </a:p>
+          <a:p>
+            <a:pPr lvl="0" algn="just">
+              <a:lnSpc>
+                <a:spcPct val="150000"/>
+              </a:lnSpc>
+            </a:pPr>
+            <a:r>
+              <a:rPr sz="2000">
+                <a:latin typeface="Times New Roman"/>
               </a:rPr>
-              <a:t>Generation</a:t>
+              <a:t>Prediction - web app + REST API</a:t>
             </a:r>
           </a:p>
         </p:txBody>

</xml_diff>